<commit_message>
Clarify Friday response flow and repair Wednesday and catch-up visuals
</commit_message>
<xml_diff>
--- a/second-placement/planning/2026-09-21-to-25/2026-09-21-to-25-Entry-Routines-Visual-v3.pptx
+++ b/second-placement/planning/2026-09-21-to-25/2026-09-21-to-25-Entry-Routines-Visual-v3.pptx
@@ -2,30 +2,30 @@
 <file path=ppt/presentation.xml><?xml version="1.0" encoding="utf-8"?>
 <p:presentation xmlns:p="http://schemas.openxmlformats.org/presentationml/2006/main">
   <p:sldMasterIdLst>
-    <p:sldMasterId xmlns:r="http://schemas.openxmlformats.org/officeDocument/2006/relationships" id="2147483648" r:id="R79c42f823b2a453c"/>
+    <p:sldMasterId xmlns:r="http://schemas.openxmlformats.org/officeDocument/2006/relationships" id="2147483648" r:id="Ra1f25ed7525b4cd9"/>
   </p:sldMasterIdLst>
   <p:notesMasterIdLst>
-    <p:notesMasterId xmlns:r="http://schemas.openxmlformats.org/officeDocument/2006/relationships" r:id="R203b21e121a24ced"/>
+    <p:notesMasterId xmlns:r="http://schemas.openxmlformats.org/officeDocument/2006/relationships" r:id="R60407ee572bd42a4"/>
   </p:notesMasterIdLst>
   <p:sldIdLst>
-    <p:sldId xmlns:r="http://schemas.openxmlformats.org/officeDocument/2006/relationships" id="256" r:id="R2a35d2e414b04cfe"/>
-    <p:sldId xmlns:r="http://schemas.openxmlformats.org/officeDocument/2006/relationships" id="257" r:id="R00c745166bed4d27"/>
-    <p:sldId xmlns:r="http://schemas.openxmlformats.org/officeDocument/2006/relationships" id="258" r:id="Rff20515c3f834c84"/>
-    <p:sldId xmlns:r="http://schemas.openxmlformats.org/officeDocument/2006/relationships" id="259" r:id="R0b6ea4f1933848fe"/>
-    <p:sldId xmlns:r="http://schemas.openxmlformats.org/officeDocument/2006/relationships" id="260" r:id="R5c71fd40945d4625"/>
-    <p:sldId xmlns:r="http://schemas.openxmlformats.org/officeDocument/2006/relationships" id="261" r:id="R694e5491c81d4f0f"/>
-    <p:sldId xmlns:r="http://schemas.openxmlformats.org/officeDocument/2006/relationships" id="262" r:id="Rc06a9e18e57b4b1e"/>
-    <p:sldId xmlns:r="http://schemas.openxmlformats.org/officeDocument/2006/relationships" id="263" r:id="Rca55dea779ce4f12"/>
-    <p:sldId xmlns:r="http://schemas.openxmlformats.org/officeDocument/2006/relationships" id="264" r:id="R2dd776c93daf492d"/>
-    <p:sldId xmlns:r="http://schemas.openxmlformats.org/officeDocument/2006/relationships" id="265" r:id="R6ef1acd105644e46"/>
-    <p:sldId xmlns:r="http://schemas.openxmlformats.org/officeDocument/2006/relationships" id="266" r:id="R836712d67f294de8"/>
-    <p:sldId xmlns:r="http://schemas.openxmlformats.org/officeDocument/2006/relationships" id="267" r:id="Raf21e4c92aee4af3"/>
-    <p:sldId xmlns:r="http://schemas.openxmlformats.org/officeDocument/2006/relationships" id="268" r:id="R0199497dab404d1b"/>
-    <p:sldId xmlns:r="http://schemas.openxmlformats.org/officeDocument/2006/relationships" id="269" r:id="R36a623c949da412f"/>
-    <p:sldId xmlns:r="http://schemas.openxmlformats.org/officeDocument/2006/relationships" id="270" r:id="Reab45b5c07e44b69"/>
-    <p:sldId xmlns:r="http://schemas.openxmlformats.org/officeDocument/2006/relationships" id="271" r:id="Rd4e2b95dbb2541dc"/>
-    <p:sldId xmlns:r="http://schemas.openxmlformats.org/officeDocument/2006/relationships" id="272" r:id="R5cc7b2fbcc924689"/>
-    <p:sldId xmlns:r="http://schemas.openxmlformats.org/officeDocument/2006/relationships" id="273" r:id="R8c3546ca0f34407c"/>
+    <p:sldId xmlns:r="http://schemas.openxmlformats.org/officeDocument/2006/relationships" id="256" r:id="Rc76cb4d53ca347e5"/>
+    <p:sldId xmlns:r="http://schemas.openxmlformats.org/officeDocument/2006/relationships" id="257" r:id="R34dc33ad7f8c4428"/>
+    <p:sldId xmlns:r="http://schemas.openxmlformats.org/officeDocument/2006/relationships" id="258" r:id="Rccecd91ea9f242ed"/>
+    <p:sldId xmlns:r="http://schemas.openxmlformats.org/officeDocument/2006/relationships" id="259" r:id="Rb9e62f09cfe446e0"/>
+    <p:sldId xmlns:r="http://schemas.openxmlformats.org/officeDocument/2006/relationships" id="260" r:id="Rd2a7b763aab34911"/>
+    <p:sldId xmlns:r="http://schemas.openxmlformats.org/officeDocument/2006/relationships" id="261" r:id="R532111f0e5ea4220"/>
+    <p:sldId xmlns:r="http://schemas.openxmlformats.org/officeDocument/2006/relationships" id="262" r:id="R54ff8ffc644b4ef3"/>
+    <p:sldId xmlns:r="http://schemas.openxmlformats.org/officeDocument/2006/relationships" id="263" r:id="Ra74cfa9244c840c1"/>
+    <p:sldId xmlns:r="http://schemas.openxmlformats.org/officeDocument/2006/relationships" id="264" r:id="R80614cdfa23c480c"/>
+    <p:sldId xmlns:r="http://schemas.openxmlformats.org/officeDocument/2006/relationships" id="265" r:id="R5e2859f4aa164f98"/>
+    <p:sldId xmlns:r="http://schemas.openxmlformats.org/officeDocument/2006/relationships" id="266" r:id="R6289569d32d747ca"/>
+    <p:sldId xmlns:r="http://schemas.openxmlformats.org/officeDocument/2006/relationships" id="267" r:id="R2d8513a2d079453a"/>
+    <p:sldId xmlns:r="http://schemas.openxmlformats.org/officeDocument/2006/relationships" id="268" r:id="Ra0656b75767d49d6"/>
+    <p:sldId xmlns:r="http://schemas.openxmlformats.org/officeDocument/2006/relationships" id="269" r:id="R7b5789b1fce840f2"/>
+    <p:sldId xmlns:r="http://schemas.openxmlformats.org/officeDocument/2006/relationships" id="270" r:id="Rc991905cbfb343c1"/>
+    <p:sldId xmlns:r="http://schemas.openxmlformats.org/officeDocument/2006/relationships" id="271" r:id="R6b7134cf0248425b"/>
+    <p:sldId xmlns:r="http://schemas.openxmlformats.org/officeDocument/2006/relationships" id="272" r:id="R0029b270c8b4425f"/>
+    <p:sldId xmlns:r="http://schemas.openxmlformats.org/officeDocument/2006/relationships" id="273" r:id="R03c8628bf21b495f"/>
   </p:sldIdLst>
   <p:sldSz cx="12192000" cy="6858000"/>
   <p:notesSz cx="6858000" cy="9144000"/>
@@ -989,67 +989,32 @@
           <a:lstStyle xmlns:a="http://schemas.openxmlformats.org/drawingml/2006/main"/>
           <a:p xmlns:a="http://schemas.openxmlformats.org/drawingml/2006/main">
             <a:r>
-              <a:t>FRIDAY, Sep. 21–25 2026. RETRIEVAL · private response. SOURCE: Chapter 1 p. 4; revisit pp. 10–15 · SBTE 4, 9–13. Printed textbook pages, not PDF viewer count. Total opener 3:00; 20s look, 40s choose, 50s check, 50s bridge, 20s buffer. Timer is teacher-controlled; on-slide times are static cues. Confirm the Sep. 25 assessment before use. If the SBTE needs a secure assessment start, omit the answer/reveal and follow-up entirely; do not coach assessed answers. Use the full routine on a review day. No new reading required before a test.</a:t>
-            </a:r>
-          </a:p>
-          <a:p xmlns:a="http://schemas.openxmlformats.org/drawingml/2006/main">
-            <a:r>
-              <a:t>EXPECTED: Sneakers are a good, a paid haircut is a service, and the anti-litter message is an idea. The printed poster is also a good; we are classifying the message, not its paper.</a:t>
-            </a:r>
-          </a:p>
-          <a:p xmlns:a="http://schemas.openxmlformats.org/drawingml/2006/main">
-            <a:r>
-              <a:t>FOLLOW-UP 1 (optional, choose at most one): If we classify the poster’s MESSAGE, what is it?</a:t>
-            </a:r>
-          </a:p>
-          <a:p xmlns:a="http://schemas.openxmlformats.org/drawingml/2006/main">
-            <a:r>
-              <a:t>FOLLOW-UP 2: Which P or function could help the salon?</a:t>
-            </a:r>
-          </a:p>
-          <a:p xmlns:a="http://schemas.openxmlformats.org/drawingml/2006/main">
-            <a:r>
-              <a:t>HARD STOP: “Pens down. Keep your response; we’re moving to today’s directions.”</a:t>
-            </a:r>
-          </a:p>
-          <a:p xmlns:a="http://schemas.openxmlformats.org/drawingml/2006/main">
-            <a:r>
-              <a:t>TRANSITION: “These are the same Chapter 1 distinctions we will use in today’s review or assessment.”</a:t>
-            </a:r>
-          </a:p>
-          <a:p xmlns:a="http://schemas.openxmlformats.org/drawingml/2006/main">
-            <a:r>
-              <a:t>SBTE: Take attendance during look/choose, scan participation discreetly, add one correction only if needed. Handoff: “Can you connect this to our notes?”</a:t>
-            </a:r>
-          </a:p>
-          <a:p xmlns:a="http://schemas.openxmlformats.org/drawingml/2006/main">
-            <a:r>
-              <a:t>MATCHED CHECK: Give a correct offering category and one linked P or function.</a:t>
-            </a:r>
-          </a:p>
-          <a:p xmlns:a="http://schemas.openxmlformats.org/drawingml/2006/main">
-            <a:r>
-              <a:t>KEY: For example: haircut is a service; promotion communicates it, pricing sets its charge, and selling helps match it to a customer.</a:t>
-            </a:r>
-          </a:p>
-          <a:p xmlns:a="http://schemas.openxmlformats.org/drawingml/2006/main">
-            <a:r>
-              <a:t>PITER: Read the scenario once. Describe the three pictures. Give 20 seconds of quiet looking, then ask everyone for a response. Accept a private written choice. No partner transition.</a:t>
-            </a:r>
-          </a:p>
-          <a:p xmlns:a="http://schemas.openxmlformats.org/drawingml/2006/main">
-            <a:r>
-              <a:t>ACCESS: Read the short directions and describe the relevant visual aloud. Offer pointing, fingers, a written letter, or a quiet spoken response. Do not require eye contact, public disclosure, a phone, or speed. Keep printed response options available. No flashing, animation, or audible countdown.</a:t>
-            </a:r>
-          </a:p>
-          <a:p xmlns:a="http://schemas.openxmlformats.org/drawingml/2006/main">
-            <a:r>
-              <a:t>VISUAL SOURCE: Fictional generated illustrations; not actual students, school events, products, or prices. Repeated images intentionally preserve the scenario between prediction and academic explanation.</a:t>
-            </a:r>
-          </a:p>
-          <a:p xmlns:a="http://schemas.openxmlformats.org/drawingml/2006/main">
-            <a:r>
-              <a:t>SCENARIO: New sneakers, a paid haircut and a keep-our-community-clean message. These are fresh examples, not Thursday’s bicycle case. Classify the message, not the poster material.</a:t>
+              <a:t>FRIDAY: 2–3 MINUTES. Chapter 1 p. 4; SBTE slide 4. Confirm assessment plans; omit this opener if it coaches assessed content.</a:t>
+            </a:r>
+          </a:p>
+          <a:p xmlns:a="http://schemas.openxmlformats.org/drawingml/2006/main">
+            <a:r>
+              <a:t>SAY: Look at the pictures. Point, show fingers, or write a number. Which picture shows a GOOD? Pause 5 seconds. Which shows a SERVICE? Pause. Which shows an IDEA? Pause. One question at a time.</a:t>
+            </a:r>
+          </a:p>
+          <a:p xmlns:a="http://schemas.openxmlformats.org/drawingml/2006/main">
+            <a:r>
+              <a:t>CHECK: 1, sneakers: a tangible good. 2, haircut: a paid service. 3, keeping our community clean: an idea. Classify the message, not the paper.</a:t>
+            </a:r>
+          </a:p>
+          <a:p xmlns:a="http://schemas.openxmlformats.org/drawingml/2006/main">
+            <a:r>
+              <a:t>Optional: What makes the haircut a service? OR Are we classifying the message or the paper? Choose at most one; 15 seconds.</a:t>
+            </a:r>
+          </a:p>
+          <a:p xmlns:a="http://schemas.openxmlformats.org/drawingml/2006/main">
+            <a:r>
+              <a:t>STOP: Different offerings. Different ways to meet a need. Then follow the confirmed class agenda. No extra P/function task in this opener; preserve the full reading and vocabulary in the lesson.</a:t>
+            </a:r>
+          </a:p>
+          <a:p xmlns:a="http://schemas.openxmlformats.org/drawingml/2006/main">
+            <a:r>
+              <a:t>SBTE: attendance and scan responses, clarify only if needed. The same pictures on question/check slides deliberately stay in place to confirm answers, not start another task.</a:t>
             </a:r>
           </a:p>
         </p:txBody>
@@ -1119,67 +1084,32 @@
           <a:lstStyle xmlns:a="http://schemas.openxmlformats.org/drawingml/2006/main"/>
           <a:p xmlns:a="http://schemas.openxmlformats.org/drawingml/2006/main">
             <a:r>
-              <a:t>FRIDAY, Sep. 21–25 2026. RETRIEVAL · private response. SOURCE: Chapter 1 p. 4; revisit pp. 10–15 · SBTE 4, 9–13. Printed textbook pages, not PDF viewer count. Total opener 3:00; 20s look, 40s choose, 50s check, 50s bridge, 20s buffer. Timer is teacher-controlled; on-slide times are static cues. Confirm the Sep. 25 assessment before use. If the SBTE needs a secure assessment start, omit the answer/reveal and follow-up entirely; do not coach assessed answers. Use the full routine on a review day. No new reading required before a test.</a:t>
-            </a:r>
-          </a:p>
-          <a:p xmlns:a="http://schemas.openxmlformats.org/drawingml/2006/main">
-            <a:r>
-              <a:t>EXPECTED: Sneakers are a good, a paid haircut is a service, and the anti-litter message is an idea. The printed poster is also a good; we are classifying the message, not its paper.</a:t>
-            </a:r>
-          </a:p>
-          <a:p xmlns:a="http://schemas.openxmlformats.org/drawingml/2006/main">
-            <a:r>
-              <a:t>FOLLOW-UP 1 (optional, choose at most one): If we classify the poster’s MESSAGE, what is it?</a:t>
-            </a:r>
-          </a:p>
-          <a:p xmlns:a="http://schemas.openxmlformats.org/drawingml/2006/main">
-            <a:r>
-              <a:t>FOLLOW-UP 2: Which P or function could help the salon?</a:t>
-            </a:r>
-          </a:p>
-          <a:p xmlns:a="http://schemas.openxmlformats.org/drawingml/2006/main">
-            <a:r>
-              <a:t>HARD STOP: “Pens down. Keep your response; we’re moving to today’s directions.”</a:t>
-            </a:r>
-          </a:p>
-          <a:p xmlns:a="http://schemas.openxmlformats.org/drawingml/2006/main">
-            <a:r>
-              <a:t>TRANSITION: “These are the same Chapter 1 distinctions we will use in today’s review or assessment.”</a:t>
-            </a:r>
-          </a:p>
-          <a:p xmlns:a="http://schemas.openxmlformats.org/drawingml/2006/main">
-            <a:r>
-              <a:t>SBTE: Take attendance during look/choose, scan participation discreetly, add one correction only if needed. Handoff: “Can you connect this to our notes?”</a:t>
-            </a:r>
-          </a:p>
-          <a:p xmlns:a="http://schemas.openxmlformats.org/drawingml/2006/main">
-            <a:r>
-              <a:t>MATCHED CHECK: Give a correct offering category and one linked P or function.</a:t>
-            </a:r>
-          </a:p>
-          <a:p xmlns:a="http://schemas.openxmlformats.org/drawingml/2006/main">
-            <a:r>
-              <a:t>KEY: For example: haircut is a service; promotion communicates it, pricing sets its charge, and selling helps match it to a customer.</a:t>
-            </a:r>
-          </a:p>
-          <a:p xmlns:a="http://schemas.openxmlformats.org/drawingml/2006/main">
-            <a:r>
-              <a:t>PITER: Reveal and explain one visual clue. Use only one follow-up if time remains. Pointing alone shows selection; check explanation in the later matched lesson check.</a:t>
-            </a:r>
-          </a:p>
-          <a:p xmlns:a="http://schemas.openxmlformats.org/drawingml/2006/main">
-            <a:r>
-              <a:t>ACCESS: Read the short directions and describe the relevant visual aloud. Offer pointing, fingers, a written letter, or a quiet spoken response. Do not require eye contact, public disclosure, a phone, or speed. Keep printed response options available. No flashing, animation, or audible countdown.</a:t>
-            </a:r>
-          </a:p>
-          <a:p xmlns:a="http://schemas.openxmlformats.org/drawingml/2006/main">
-            <a:r>
-              <a:t>VISUAL SOURCE: Fictional generated illustrations; not actual students, school events, products, or prices. Repeated images intentionally preserve the scenario between prediction and academic explanation.</a:t>
-            </a:r>
-          </a:p>
-          <a:p xmlns:a="http://schemas.openxmlformats.org/drawingml/2006/main">
-            <a:r>
-              <a:t>SCENARIO: New sneakers, a paid haircut and a keep-our-community-clean message. These are fresh examples, not Thursday’s bicycle case. Classify the message, not the poster material.</a:t>
+              <a:t>FRIDAY: 2–3 MINUTES. Chapter 1 p. 4; SBTE slide 4. Confirm assessment plans; omit this opener if it coaches assessed content.</a:t>
+            </a:r>
+          </a:p>
+          <a:p xmlns:a="http://schemas.openxmlformats.org/drawingml/2006/main">
+            <a:r>
+              <a:t>SAY: Look at the pictures. Point, show fingers, or write a number. Which picture shows a GOOD? Pause 5 seconds. Which shows a SERVICE? Pause. Which shows an IDEA? Pause. One question at a time.</a:t>
+            </a:r>
+          </a:p>
+          <a:p xmlns:a="http://schemas.openxmlformats.org/drawingml/2006/main">
+            <a:r>
+              <a:t>CHECK: 1, sneakers: a tangible good. 2, haircut: a paid service. 3, keeping our community clean: an idea. Classify the message, not the paper.</a:t>
+            </a:r>
+          </a:p>
+          <a:p xmlns:a="http://schemas.openxmlformats.org/drawingml/2006/main">
+            <a:r>
+              <a:t>Optional: What makes the haircut a service? OR Are we classifying the message or the paper? Choose at most one; 15 seconds.</a:t>
+            </a:r>
+          </a:p>
+          <a:p xmlns:a="http://schemas.openxmlformats.org/drawingml/2006/main">
+            <a:r>
+              <a:t>STOP: Different offerings. Different ways to meet a need. Then follow the confirmed class agenda. No extra P/function task in this opener; preserve the full reading and vocabulary in the lesson.</a:t>
+            </a:r>
+          </a:p>
+          <a:p xmlns:a="http://schemas.openxmlformats.org/drawingml/2006/main">
+            <a:r>
+              <a:t>SBTE: attendance and scan responses, clarify only if needed. The same pictures on question/check slides deliberately stay in place to confirm answers, not start another task.</a:t>
             </a:r>
           </a:p>
         </p:txBody>
@@ -1249,67 +1179,32 @@
           <a:lstStyle xmlns:a="http://schemas.openxmlformats.org/drawingml/2006/main"/>
           <a:p xmlns:a="http://schemas.openxmlformats.org/drawingml/2006/main">
             <a:r>
-              <a:t>FRIDAY, Sep. 21–25 2026. RETRIEVAL · private response. SOURCE: Chapter 1 p. 4; revisit pp. 10–15 · SBTE 4, 9–13. Printed textbook pages, not PDF viewer count. Total opener 3:00; 20s look, 40s choose, 50s check, 50s bridge, 20s buffer. Timer is teacher-controlled; on-slide times are static cues. Confirm the Sep. 25 assessment before use. If the SBTE needs a secure assessment start, omit the answer/reveal and follow-up entirely; do not coach assessed answers. Use the full routine on a review day. No new reading required before a test.</a:t>
-            </a:r>
-          </a:p>
-          <a:p xmlns:a="http://schemas.openxmlformats.org/drawingml/2006/main">
-            <a:r>
-              <a:t>EXPECTED: Sneakers are a good, a paid haircut is a service, and the anti-litter message is an idea. The printed poster is also a good; we are classifying the message, not its paper.</a:t>
-            </a:r>
-          </a:p>
-          <a:p xmlns:a="http://schemas.openxmlformats.org/drawingml/2006/main">
-            <a:r>
-              <a:t>FOLLOW-UP 1 (optional, choose at most one): If we classify the poster’s MESSAGE, what is it?</a:t>
-            </a:r>
-          </a:p>
-          <a:p xmlns:a="http://schemas.openxmlformats.org/drawingml/2006/main">
-            <a:r>
-              <a:t>FOLLOW-UP 2: Which P or function could help the salon?</a:t>
-            </a:r>
-          </a:p>
-          <a:p xmlns:a="http://schemas.openxmlformats.org/drawingml/2006/main">
-            <a:r>
-              <a:t>HARD STOP: “Pens down. Keep your response; we’re moving to today’s directions.”</a:t>
-            </a:r>
-          </a:p>
-          <a:p xmlns:a="http://schemas.openxmlformats.org/drawingml/2006/main">
-            <a:r>
-              <a:t>TRANSITION: “These are the same Chapter 1 distinctions we will use in today’s review or assessment.”</a:t>
-            </a:r>
-          </a:p>
-          <a:p xmlns:a="http://schemas.openxmlformats.org/drawingml/2006/main">
-            <a:r>
-              <a:t>SBTE: Take attendance during look/choose, scan participation discreetly, add one correction only if needed. Handoff: “Can you connect this to our notes?”</a:t>
-            </a:r>
-          </a:p>
-          <a:p xmlns:a="http://schemas.openxmlformats.org/drawingml/2006/main">
-            <a:r>
-              <a:t>MATCHED CHECK: Give a correct offering category and one linked P or function.</a:t>
-            </a:r>
-          </a:p>
-          <a:p xmlns:a="http://schemas.openxmlformats.org/drawingml/2006/main">
-            <a:r>
-              <a:t>KEY: For example: haircut is a service; promotion communicates it, pricing sets its charge, and selling helps match it to a customer.</a:t>
-            </a:r>
-          </a:p>
-          <a:p xmlns:a="http://schemas.openxmlformats.org/drawingml/2006/main">
-            <a:r>
-              <a:t>PITER: Say the one-line closer. Students locate the named heading, not an unfamiliar page number alone. End the opener, then use the appropriate notes/readings.</a:t>
-            </a:r>
-          </a:p>
-          <a:p xmlns:a="http://schemas.openxmlformats.org/drawingml/2006/main">
-            <a:r>
-              <a:t>ACCESS: Read the short directions and describe the relevant visual aloud. Offer pointing, fingers, a written letter, or a quiet spoken response. Do not require eye contact, public disclosure, a phone, or speed. Keep printed response options available. No flashing, animation, or audible countdown.</a:t>
-            </a:r>
-          </a:p>
-          <a:p xmlns:a="http://schemas.openxmlformats.org/drawingml/2006/main">
-            <a:r>
-              <a:t>VISUAL SOURCE: Fictional generated illustrations; not actual students, school events, products, or prices. Repeated images intentionally preserve the scenario between prediction and academic explanation.</a:t>
-            </a:r>
-          </a:p>
-          <a:p xmlns:a="http://schemas.openxmlformats.org/drawingml/2006/main">
-            <a:r>
-              <a:t>SCENARIO: New sneakers, a paid haircut and a keep-our-community-clean message. These are fresh examples, not Thursday’s bicycle case. Classify the message, not the poster material.</a:t>
+              <a:t>FRIDAY: 2–3 MINUTES. Chapter 1 p. 4; SBTE slide 4. Confirm assessment plans; omit this opener if it coaches assessed content.</a:t>
+            </a:r>
+          </a:p>
+          <a:p xmlns:a="http://schemas.openxmlformats.org/drawingml/2006/main">
+            <a:r>
+              <a:t>SAY: Look at the pictures. Point, show fingers, or write a number. Which picture shows a GOOD? Pause 5 seconds. Which shows a SERVICE? Pause. Which shows an IDEA? Pause. One question at a time.</a:t>
+            </a:r>
+          </a:p>
+          <a:p xmlns:a="http://schemas.openxmlformats.org/drawingml/2006/main">
+            <a:r>
+              <a:t>CHECK: 1, sneakers: a tangible good. 2, haircut: a paid service. 3, keeping our community clean: an idea. Classify the message, not the paper.</a:t>
+            </a:r>
+          </a:p>
+          <a:p xmlns:a="http://schemas.openxmlformats.org/drawingml/2006/main">
+            <a:r>
+              <a:t>Optional: What makes the haircut a service? OR Are we classifying the message or the paper? Choose at most one; 15 seconds.</a:t>
+            </a:r>
+          </a:p>
+          <a:p xmlns:a="http://schemas.openxmlformats.org/drawingml/2006/main">
+            <a:r>
+              <a:t>STOP: Different offerings. Different ways to meet a need. Then follow the confirmed class agenda. No extra P/function task in this opener; preserve the full reading and vocabulary in the lesson.</a:t>
+            </a:r>
+          </a:p>
+          <a:p xmlns:a="http://schemas.openxmlformats.org/drawingml/2006/main">
+            <a:r>
+              <a:t>SBTE: attendance and scan responses, clarify only if needed. The same pictures on question/check slides deliberately stay in place to confirm answers, not start another task.</a:t>
             </a:r>
           </a:p>
         </p:txBody>
@@ -1379,62 +1274,32 @@
           <a:lstStyle xmlns:a="http://schemas.openxmlformats.org/drawingml/2006/main"/>
           <a:p xmlns:a="http://schemas.openxmlformats.org/drawingml/2006/main">
             <a:r>
-              <a:t>MONDAY, Sep. 21–25 2026. CATCH-UP · use INSTEAD of main Monday route. SOURCE: Chapter 1 pp. 7–9 · SBTE 7–8. Printed textbook pages, not PDF viewer count. Total opener 3:00; 20s look, 40s choose, 50s check, 50s bridge, 20s buffer. Timer is teacher-controlled; on-slide times are static cues. Use this route if the actual section stop is before pp. 7–9/slide 8 completion. Do not advance this section just because the calendar says Monday. Financial activities may need a short note review before reading. Complete missing work first.</a:t>
-            </a:r>
-          </a:p>
-          <a:p xmlns:a="http://schemas.openxmlformats.org/drawingml/2006/main">
-            <a:r>
-              <a:t>EXPECTED: A and B. The book includes goods and services as products. The recycling message need not be sold. Then identify wider contributions: jobs, wages, markets, and taxes. Do not infer every depicted worker’s pay.</a:t>
-            </a:r>
-          </a:p>
-          <a:p xmlns:a="http://schemas.openxmlformats.org/drawingml/2006/main">
-            <a:r>
-              <a:t>FOLLOW-UP 1 (optional, choose at most one): How is a service also a product?</a:t>
-            </a:r>
-          </a:p>
-          <a:p xmlns:a="http://schemas.openxmlformats.org/drawingml/2006/main">
-            <a:r>
-              <a:t>FOLLOW-UP 2: Who besides customers could benefit from the business?</a:t>
-            </a:r>
-          </a:p>
-          <a:p xmlns:a="http://schemas.openxmlformats.org/drawingml/2006/main">
-            <a:r>
-              <a:t>HARD STOP: “Both goods and paid services count. Let’s use the reading to check the wider effects.”</a:t>
-            </a:r>
-          </a:p>
-          <a:p xmlns:a="http://schemas.openxmlformats.org/drawingml/2006/main">
-            <a:r>
-              <a:t>TRANSITION: “Finish financial activities on page 7, then pages 8–9 explain how businesses affect their communities.”</a:t>
-            </a:r>
-          </a:p>
-          <a:p xmlns:a="http://schemas.openxmlformats.org/drawingml/2006/main">
-            <a:r>
-              <a:t>SBTE: Take attendance during look/choose, scan participation discreetly, add one correction only if needed. Handoff: “Can you connect this to our notes?”</a:t>
-            </a:r>
-          </a:p>
-          <a:p xmlns:a="http://schemas.openxmlformats.org/drawingml/2006/main">
-            <a:r>
-              <a:t>MATCHED CHECK: Name one contribution a business makes beyond its sale.</a:t>
-            </a:r>
-          </a:p>
-          <a:p xmlns:a="http://schemas.openxmlformats.org/drawingml/2006/main">
-            <a:r>
-              <a:t>KEY: Employment/wages or taxes supporting public services; markets enabling exchange also accepted.</a:t>
-            </a:r>
-          </a:p>
-          <a:p xmlns:a="http://schemas.openxmlformats.org/drawingml/2006/main">
-            <a:r>
-              <a:t>PITER: Read the scenario once. Describe the three pictures. Give 20 seconds of quiet looking, then ask everyone for a response. Accept a private written choice. No partner transition.</a:t>
-            </a:r>
-          </a:p>
-          <a:p xmlns:a="http://schemas.openxmlformats.org/drawingml/2006/main">
-            <a:r>
-              <a:t>ACCESS: Read the short directions and describe the relevant visual aloud. Offer pointing, fingers, a written letter, or a quiet spoken response. Do not require eye contact, public disclosure, a phone, or speed. Keep printed response options available. No flashing, animation, or audible countdown.</a:t>
-            </a:r>
-          </a:p>
-          <a:p xmlns:a="http://schemas.openxmlformats.org/drawingml/2006/main">
-            <a:r>
-              <a:t>VISUAL SOURCE: Fictional generated illustrations; not actual students, school events, products, or prices. Repeated images intentionally preserve the scenario between prediction and academic explanation.</a:t>
+              <a:t>OPTIONAL MONDAY CATCH-UP: use slides 16–18 INSTEAD OF 1–3 only if the section still owes pp. 7–9. Never both. Chapter 1 pp. 7–9; SBTE 7–8.</a:t>
+            </a:r>
+          </a:p>
+          <a:p xmlns:a="http://schemas.openxmlformats.org/drawingml/2006/main">
+            <a:r>
+              <a:t>SAY: The customer gets bread. Besides the customer, who else can benefit? Show 2, 3, or both. Look 20 seconds; choose 40 seconds.</a:t>
+            </a:r>
+          </a:p>
+          <a:p xmlns:a="http://schemas.openxmlformats.org/drawingml/2006/main">
+            <a:r>
+              <a:t>CHECK: Both. The worker earns pay. Business taxes can help fund public services. Fictional illustration, not a claim of a direct donation to a school.</a:t>
+            </a:r>
+          </a:p>
+          <a:p xmlns:a="http://schemas.openxmlformats.org/drawingml/2006/main">
+            <a:r>
+              <a:t>STOP: Keep those two effects: jobs and public services.</a:t>
+            </a:r>
+          </a:p>
+          <a:p xmlns:a="http://schemas.openxmlformats.org/drawingml/2006/main">
+            <a:r>
+              <a:t>TRANSITION: Finish Financial Activities on page 7, then read Ways Businesses Contribute to Society on pages 8–9. Find employment and taxes.</a:t>
+            </a:r>
+          </a:p>
+          <a:p xmlns:a="http://schemas.openxmlformats.org/drawingml/2006/main">
+            <a:r>
+              <a:t>SBTE takes attendance and resumes the actual stopping point. At most 3 minutes. Accept pointing, fingers, writing, or quiet spoken answers.</a:t>
             </a:r>
           </a:p>
         </p:txBody>
@@ -1504,62 +1369,32 @@
           <a:lstStyle xmlns:a="http://schemas.openxmlformats.org/drawingml/2006/main"/>
           <a:p xmlns:a="http://schemas.openxmlformats.org/drawingml/2006/main">
             <a:r>
-              <a:t>MONDAY, Sep. 21–25 2026. CATCH-UP · use INSTEAD of main Monday route. SOURCE: Chapter 1 pp. 7–9 · SBTE 7–8. Printed textbook pages, not PDF viewer count. Total opener 3:00; 20s look, 40s choose, 50s check, 50s bridge, 20s buffer. Timer is teacher-controlled; on-slide times are static cues. Use this route if the actual section stop is before pp. 7–9/slide 8 completion. Do not advance this section just because the calendar says Monday. Financial activities may need a short note review before reading. Complete missing work first.</a:t>
-            </a:r>
-          </a:p>
-          <a:p xmlns:a="http://schemas.openxmlformats.org/drawingml/2006/main">
-            <a:r>
-              <a:t>EXPECTED: A and B. The book includes goods and services as products. The recycling message need not be sold. Then identify wider contributions: jobs, wages, markets, and taxes. Do not infer every depicted worker’s pay.</a:t>
-            </a:r>
-          </a:p>
-          <a:p xmlns:a="http://schemas.openxmlformats.org/drawingml/2006/main">
-            <a:r>
-              <a:t>FOLLOW-UP 1 (optional, choose at most one): How is a service also a product?</a:t>
-            </a:r>
-          </a:p>
-          <a:p xmlns:a="http://schemas.openxmlformats.org/drawingml/2006/main">
-            <a:r>
-              <a:t>FOLLOW-UP 2: Who besides customers could benefit from the business?</a:t>
-            </a:r>
-          </a:p>
-          <a:p xmlns:a="http://schemas.openxmlformats.org/drawingml/2006/main">
-            <a:r>
-              <a:t>HARD STOP: “Both goods and paid services count. Let’s use the reading to check the wider effects.”</a:t>
-            </a:r>
-          </a:p>
-          <a:p xmlns:a="http://schemas.openxmlformats.org/drawingml/2006/main">
-            <a:r>
-              <a:t>TRANSITION: “Finish financial activities on page 7, then pages 8–9 explain how businesses affect their communities.”</a:t>
-            </a:r>
-          </a:p>
-          <a:p xmlns:a="http://schemas.openxmlformats.org/drawingml/2006/main">
-            <a:r>
-              <a:t>SBTE: Take attendance during look/choose, scan participation discreetly, add one correction only if needed. Handoff: “Can you connect this to our notes?”</a:t>
-            </a:r>
-          </a:p>
-          <a:p xmlns:a="http://schemas.openxmlformats.org/drawingml/2006/main">
-            <a:r>
-              <a:t>MATCHED CHECK: Name one contribution a business makes beyond its sale.</a:t>
-            </a:r>
-          </a:p>
-          <a:p xmlns:a="http://schemas.openxmlformats.org/drawingml/2006/main">
-            <a:r>
-              <a:t>KEY: Employment/wages or taxes supporting public services; markets enabling exchange also accepted.</a:t>
-            </a:r>
-          </a:p>
-          <a:p xmlns:a="http://schemas.openxmlformats.org/drawingml/2006/main">
-            <a:r>
-              <a:t>PITER: Reveal and explain one visual clue. Use only one follow-up if time remains. Pointing alone shows selection; check explanation in the later matched lesson check.</a:t>
-            </a:r>
-          </a:p>
-          <a:p xmlns:a="http://schemas.openxmlformats.org/drawingml/2006/main">
-            <a:r>
-              <a:t>ACCESS: Read the short directions and describe the relevant visual aloud. Offer pointing, fingers, a written letter, or a quiet spoken response. Do not require eye contact, public disclosure, a phone, or speed. Keep printed response options available. No flashing, animation, or audible countdown.</a:t>
-            </a:r>
-          </a:p>
-          <a:p xmlns:a="http://schemas.openxmlformats.org/drawingml/2006/main">
-            <a:r>
-              <a:t>VISUAL SOURCE: Fictional generated illustrations; not actual students, school events, products, or prices. Repeated images intentionally preserve the scenario between prediction and academic explanation.</a:t>
+              <a:t>OPTIONAL MONDAY CATCH-UP: use slides 16–18 INSTEAD OF 1–3 only if the section still owes pp. 7–9. Never both. Chapter 1 pp. 7–9; SBTE 7–8.</a:t>
+            </a:r>
+          </a:p>
+          <a:p xmlns:a="http://schemas.openxmlformats.org/drawingml/2006/main">
+            <a:r>
+              <a:t>SAY: The customer gets bread. Besides the customer, who else can benefit? Show 2, 3, or both. Look 20 seconds; choose 40 seconds.</a:t>
+            </a:r>
+          </a:p>
+          <a:p xmlns:a="http://schemas.openxmlformats.org/drawingml/2006/main">
+            <a:r>
+              <a:t>CHECK: Both. The worker earns pay. Business taxes can help fund public services. Fictional illustration, not a claim of a direct donation to a school.</a:t>
+            </a:r>
+          </a:p>
+          <a:p xmlns:a="http://schemas.openxmlformats.org/drawingml/2006/main">
+            <a:r>
+              <a:t>STOP: Keep those two effects: jobs and public services.</a:t>
+            </a:r>
+          </a:p>
+          <a:p xmlns:a="http://schemas.openxmlformats.org/drawingml/2006/main">
+            <a:r>
+              <a:t>TRANSITION: Finish Financial Activities on page 7, then read Ways Businesses Contribute to Society on pages 8–9. Find employment and taxes.</a:t>
+            </a:r>
+          </a:p>
+          <a:p xmlns:a="http://schemas.openxmlformats.org/drawingml/2006/main">
+            <a:r>
+              <a:t>SBTE takes attendance and resumes the actual stopping point. At most 3 minutes. Accept pointing, fingers, writing, or quiet spoken answers.</a:t>
             </a:r>
           </a:p>
         </p:txBody>
@@ -1629,62 +1464,32 @@
           <a:lstStyle xmlns:a="http://schemas.openxmlformats.org/drawingml/2006/main"/>
           <a:p xmlns:a="http://schemas.openxmlformats.org/drawingml/2006/main">
             <a:r>
-              <a:t>MONDAY, Sep. 21–25 2026. CATCH-UP · use INSTEAD of main Monday route. SOURCE: Chapter 1 pp. 7–9 · SBTE 7–8. Printed textbook pages, not PDF viewer count. Total opener 3:00; 20s look, 40s choose, 50s check, 50s bridge, 20s buffer. Timer is teacher-controlled; on-slide times are static cues. Use this route if the actual section stop is before pp. 7–9/slide 8 completion. Do not advance this section just because the calendar says Monday. Financial activities may need a short note review before reading. Complete missing work first.</a:t>
-            </a:r>
-          </a:p>
-          <a:p xmlns:a="http://schemas.openxmlformats.org/drawingml/2006/main">
-            <a:r>
-              <a:t>EXPECTED: A and B. The book includes goods and services as products. The recycling message need not be sold. Then identify wider contributions: jobs, wages, markets, and taxes. Do not infer every depicted worker’s pay.</a:t>
-            </a:r>
-          </a:p>
-          <a:p xmlns:a="http://schemas.openxmlformats.org/drawingml/2006/main">
-            <a:r>
-              <a:t>FOLLOW-UP 1 (optional, choose at most one): How is a service also a product?</a:t>
-            </a:r>
-          </a:p>
-          <a:p xmlns:a="http://schemas.openxmlformats.org/drawingml/2006/main">
-            <a:r>
-              <a:t>FOLLOW-UP 2: Who besides customers could benefit from the business?</a:t>
-            </a:r>
-          </a:p>
-          <a:p xmlns:a="http://schemas.openxmlformats.org/drawingml/2006/main">
-            <a:r>
-              <a:t>HARD STOP: “Both goods and paid services count. Let’s use the reading to check the wider effects.”</a:t>
-            </a:r>
-          </a:p>
-          <a:p xmlns:a="http://schemas.openxmlformats.org/drawingml/2006/main">
-            <a:r>
-              <a:t>TRANSITION: “Finish financial activities on page 7, then pages 8–9 explain how businesses affect their communities.”</a:t>
-            </a:r>
-          </a:p>
-          <a:p xmlns:a="http://schemas.openxmlformats.org/drawingml/2006/main">
-            <a:r>
-              <a:t>SBTE: Take attendance during look/choose, scan participation discreetly, add one correction only if needed. Handoff: “Can you connect this to our notes?”</a:t>
-            </a:r>
-          </a:p>
-          <a:p xmlns:a="http://schemas.openxmlformats.org/drawingml/2006/main">
-            <a:r>
-              <a:t>MATCHED CHECK: Name one contribution a business makes beyond its sale.</a:t>
-            </a:r>
-          </a:p>
-          <a:p xmlns:a="http://schemas.openxmlformats.org/drawingml/2006/main">
-            <a:r>
-              <a:t>KEY: Employment/wages or taxes supporting public services; markets enabling exchange also accepted.</a:t>
-            </a:r>
-          </a:p>
-          <a:p xmlns:a="http://schemas.openxmlformats.org/drawingml/2006/main">
-            <a:r>
-              <a:t>PITER: Say the one-line closer. Students locate the named heading, not an unfamiliar page number alone. End the opener, then use the appropriate notes/readings.</a:t>
-            </a:r>
-          </a:p>
-          <a:p xmlns:a="http://schemas.openxmlformats.org/drawingml/2006/main">
-            <a:r>
-              <a:t>ACCESS: Read the short directions and describe the relevant visual aloud. Offer pointing, fingers, a written letter, or a quiet spoken response. Do not require eye contact, public disclosure, a phone, or speed. Keep printed response options available. No flashing, animation, or audible countdown.</a:t>
-            </a:r>
-          </a:p>
-          <a:p xmlns:a="http://schemas.openxmlformats.org/drawingml/2006/main">
-            <a:r>
-              <a:t>VISUAL SOURCE: Fictional generated illustrations; not actual students, school events, products, or prices. Repeated images intentionally preserve the scenario between prediction and academic explanation.</a:t>
+              <a:t>OPTIONAL MONDAY CATCH-UP: use slides 16–18 INSTEAD OF 1–3 only if the section still owes pp. 7–9. Never both. Chapter 1 pp. 7–9; SBTE 7–8.</a:t>
+            </a:r>
+          </a:p>
+          <a:p xmlns:a="http://schemas.openxmlformats.org/drawingml/2006/main">
+            <a:r>
+              <a:t>SAY: The customer gets bread. Besides the customer, who else can benefit? Show 2, 3, or both. Look 20 seconds; choose 40 seconds.</a:t>
+            </a:r>
+          </a:p>
+          <a:p xmlns:a="http://schemas.openxmlformats.org/drawingml/2006/main">
+            <a:r>
+              <a:t>CHECK: Both. The worker earns pay. Business taxes can help fund public services. Fictional illustration, not a claim of a direct donation to a school.</a:t>
+            </a:r>
+          </a:p>
+          <a:p xmlns:a="http://schemas.openxmlformats.org/drawingml/2006/main">
+            <a:r>
+              <a:t>STOP: Keep those two effects: jobs and public services.</a:t>
+            </a:r>
+          </a:p>
+          <a:p xmlns:a="http://schemas.openxmlformats.org/drawingml/2006/main">
+            <a:r>
+              <a:t>TRANSITION: Finish Financial Activities on page 7, then read Ways Businesses Contribute to Society on pages 8–9. Find employment and taxes.</a:t>
+            </a:r>
+          </a:p>
+          <a:p xmlns:a="http://schemas.openxmlformats.org/drawingml/2006/main">
+            <a:r>
+              <a:t>SBTE takes attendance and resumes the actual stopping point. At most 3 minutes. Accept pointing, fingers, writing, or quiet spoken answers.</a:t>
             </a:r>
           </a:p>
         </p:txBody>
@@ -2452,6 +2257,11 @@
               <a:t>VISUAL SOURCE: Fictional generated illustrations; not actual students, school events, products, or prices. Repeated images intentionally preserve the scenario between prediction and academic explanation.</a:t>
             </a:r>
           </a:p>
+          <a:p xmlns:a="http://schemas.openxmlformats.org/drawingml/2006/main">
+            <a:r>
+              <a:t>VISUAL CUES: A shows a leading question, B listens to players, spectators and someone not interested, C substitutes the organizer’s favorite. Ask students to choose the question, using the paired scene for meaning. B leaves room for honest answers. Source: fictional generated triptych; Chapter 1 pp. 13–15 and SBTE slides 11–13.</a:t>
+            </a:r>
+          </a:p>
         </p:txBody>
       </p:sp>
       <p:sp>
@@ -2575,6 +2385,11 @@
           <a:p xmlns:a="http://schemas.openxmlformats.org/drawingml/2006/main">
             <a:r>
               <a:t>VISUAL SOURCE: Fictional generated illustrations; not actual students, school events, products, or prices. Repeated images intentionally preserve the scenario between prediction and academic explanation.</a:t>
+            </a:r>
+          </a:p>
+          <a:p xmlns:a="http://schemas.openxmlformats.org/drawingml/2006/main">
+            <a:r>
+              <a:t>VISUAL CUES: A shows a leading question, B listens to players, spectators and someone not interested, C substitutes the organizer’s favorite. Ask students to choose the question, using the paired scene for meaning. B leaves room for honest answers. Source: fictional generated triptych; Chapter 1 pp. 13–15 and SBTE slides 11–13.</a:t>
             </a:r>
           </a:p>
         </p:txBody>
@@ -2767,7 +2582,7 @@
   </p:cSld>
   <p:clrMap bg1="lt1" tx1="dk1" bg2="lt2" tx2="dk2" accent1="accent1" accent2="accent2" accent3="accent3" accent4="accent4" accent5="accent5" accent6="accent6" hlink="hlink" folHlink="folHlink"/>
   <p:sldLayoutIdLst>
-    <p:sldLayoutId xmlns:r="http://schemas.openxmlformats.org/officeDocument/2006/relationships" id="2147483649" r:id="R231984dc924d497d"/>
+    <p:sldLayoutId xmlns:r="http://schemas.openxmlformats.org/officeDocument/2006/relationships" id="2147483649" r:id="Ra9bbabbda55a41ca"/>
   </p:sldLayoutIdLst>
   <p:txStyles>
     <p:titleStyle>
@@ -3642,7 +3457,7 @@
           <p:nvPr/>
         </p:nvPicPr>
         <p:blipFill>
-          <a:blip xmlns:r="http://schemas.openxmlformats.org/officeDocument/2006/relationships" xmlns:a="http://schemas.openxmlformats.org/drawingml/2006/main" r:embed="Rc9180426ceae4bb0"/>
+          <a:blip xmlns:r="http://schemas.openxmlformats.org/officeDocument/2006/relationships" xmlns:a="http://schemas.openxmlformats.org/drawingml/2006/main" r:embed="R6cf6b60706724637"/>
           <a:stretch xmlns:a="http://schemas.openxmlformats.org/drawingml/2006/main"/>
         </p:blipFill>
         <p:spPr>
@@ -3722,7 +3537,7 @@
           <p:nvPr/>
         </p:nvPicPr>
         <p:blipFill>
-          <a:blip xmlns:r="http://schemas.openxmlformats.org/officeDocument/2006/relationships" xmlns:a="http://schemas.openxmlformats.org/drawingml/2006/main" r:embed="R2c2f259c3c774821"/>
+          <a:blip xmlns:r="http://schemas.openxmlformats.org/officeDocument/2006/relationships" xmlns:a="http://schemas.openxmlformats.org/drawingml/2006/main" r:embed="R048ed9a052734c42"/>
           <a:stretch xmlns:a="http://schemas.openxmlformats.org/drawingml/2006/main"/>
         </p:blipFill>
         <p:spPr>
@@ -3802,7 +3617,7 @@
           <p:nvPr/>
         </p:nvPicPr>
         <p:blipFill>
-          <a:blip xmlns:r="http://schemas.openxmlformats.org/officeDocument/2006/relationships" xmlns:a="http://schemas.openxmlformats.org/drawingml/2006/main" r:embed="R128d03495ea34224"/>
+          <a:blip xmlns:r="http://schemas.openxmlformats.org/officeDocument/2006/relationships" xmlns:a="http://schemas.openxmlformats.org/drawingml/2006/main" r:embed="R9f9c319220674c9c"/>
           <a:stretch xmlns:a="http://schemas.openxmlformats.org/drawingml/2006/main"/>
         </p:blipFill>
         <p:spPr>
@@ -4377,7 +4192,7 @@
           <p:nvPr/>
         </p:nvPicPr>
         <p:blipFill>
-          <a:blip xmlns:r="http://schemas.openxmlformats.org/officeDocument/2006/relationships" xmlns:a="http://schemas.openxmlformats.org/drawingml/2006/main" r:embed="R9d9776f8d7264ebd"/>
+          <a:blip xmlns:r="http://schemas.openxmlformats.org/officeDocument/2006/relationships" xmlns:a="http://schemas.openxmlformats.org/drawingml/2006/main" r:embed="R206d5ca7b9934910"/>
           <a:stretch xmlns:a="http://schemas.openxmlformats.org/drawingml/2006/main"/>
         </p:blipFill>
         <p:spPr>
@@ -4457,7 +4272,7 @@
           <p:nvPr/>
         </p:nvPicPr>
         <p:blipFill>
-          <a:blip xmlns:r="http://schemas.openxmlformats.org/officeDocument/2006/relationships" xmlns:a="http://schemas.openxmlformats.org/drawingml/2006/main" r:embed="Rbb09e1b62f244361"/>
+          <a:blip xmlns:r="http://schemas.openxmlformats.org/officeDocument/2006/relationships" xmlns:a="http://schemas.openxmlformats.org/drawingml/2006/main" r:embed="Ra002ad2869134547"/>
           <a:stretch xmlns:a="http://schemas.openxmlformats.org/drawingml/2006/main"/>
         </p:blipFill>
         <p:spPr>
@@ -4537,7 +4352,7 @@
           <p:nvPr/>
         </p:nvPicPr>
         <p:blipFill>
-          <a:blip xmlns:r="http://schemas.openxmlformats.org/officeDocument/2006/relationships" xmlns:a="http://schemas.openxmlformats.org/drawingml/2006/main" r:embed="R4cdaebc955d342ae"/>
+          <a:blip xmlns:r="http://schemas.openxmlformats.org/officeDocument/2006/relationships" xmlns:a="http://schemas.openxmlformats.org/drawingml/2006/main" r:embed="R987b3b310ff541ef"/>
           <a:stretch xmlns:a="http://schemas.openxmlformats.org/drawingml/2006/main"/>
         </p:blipFill>
         <p:spPr>
@@ -5054,7 +4869,7 @@
           <p:nvPr/>
         </p:nvPicPr>
         <p:blipFill>
-          <a:blip xmlns:r="http://schemas.openxmlformats.org/officeDocument/2006/relationships" xmlns:a="http://schemas.openxmlformats.org/drawingml/2006/main" r:embed="Rd93b61d229c348c7"/>
+          <a:blip xmlns:r="http://schemas.openxmlformats.org/officeDocument/2006/relationships" xmlns:a="http://schemas.openxmlformats.org/drawingml/2006/main" r:embed="R9901eaf75c8e4962"/>
           <a:stretch xmlns:a="http://schemas.openxmlformats.org/drawingml/2006/main"/>
         </p:blipFill>
         <p:spPr>
@@ -5134,7 +4949,7 @@
           <p:nvPr/>
         </p:nvPicPr>
         <p:blipFill>
-          <a:blip xmlns:r="http://schemas.openxmlformats.org/officeDocument/2006/relationships" xmlns:a="http://schemas.openxmlformats.org/drawingml/2006/main" r:embed="Rfb6b8f3e70314032"/>
+          <a:blip xmlns:r="http://schemas.openxmlformats.org/officeDocument/2006/relationships" xmlns:a="http://schemas.openxmlformats.org/drawingml/2006/main" r:embed="R4e0638f7620a4b41"/>
           <a:stretch xmlns:a="http://schemas.openxmlformats.org/drawingml/2006/main"/>
         </p:blipFill>
         <p:spPr>
@@ -5214,7 +5029,7 @@
           <p:nvPr/>
         </p:nvPicPr>
         <p:blipFill>
-          <a:blip xmlns:r="http://schemas.openxmlformats.org/officeDocument/2006/relationships" xmlns:a="http://schemas.openxmlformats.org/drawingml/2006/main" r:embed="R4bb3c477241c45e5"/>
+          <a:blip xmlns:r="http://schemas.openxmlformats.org/officeDocument/2006/relationships" xmlns:a="http://schemas.openxmlformats.org/drawingml/2006/main" r:embed="Rd3fc59e6328a4367"/>
           <a:stretch xmlns:a="http://schemas.openxmlformats.org/drawingml/2006/main"/>
         </p:blipFill>
         <p:spPr>
@@ -5731,7 +5546,7 @@
           <p:nvPr/>
         </p:nvPicPr>
         <p:blipFill>
-          <a:blip xmlns:r="http://schemas.openxmlformats.org/officeDocument/2006/relationships" xmlns:a="http://schemas.openxmlformats.org/drawingml/2006/main" r:embed="R08f2aba8e5134b4f"/>
+          <a:blip xmlns:r="http://schemas.openxmlformats.org/officeDocument/2006/relationships" xmlns:a="http://schemas.openxmlformats.org/drawingml/2006/main" r:embed="R075eb0c19c75438d"/>
           <a:stretch xmlns:a="http://schemas.openxmlformats.org/drawingml/2006/main"/>
         </p:blipFill>
         <p:spPr>
@@ -6350,7 +6165,7 @@
                 <a:ea typeface="Arial"/>
                 <a:cs typeface="Arial"/>
               </a:rPr>
-              <a:t>Match G = good, S = service, I = idea.</a:t>
+              <a:t>Which picture shows a GOOD? Show its number.</a:t>
             </a:r>
           </a:p>
         </p:txBody>
@@ -6364,7 +6179,7 @@
           <p:nvPr/>
         </p:nvPicPr>
         <p:blipFill>
-          <a:blip xmlns:r="http://schemas.openxmlformats.org/officeDocument/2006/relationships" xmlns:a="http://schemas.openxmlformats.org/drawingml/2006/main" r:embed="R0a2a4395bf1345da"/>
+          <a:blip xmlns:r="http://schemas.openxmlformats.org/officeDocument/2006/relationships" xmlns:a="http://schemas.openxmlformats.org/drawingml/2006/main" r:embed="R07e3e318f1044145"/>
           <a:stretch xmlns:a="http://schemas.openxmlformats.org/drawingml/2006/main"/>
         </p:blipFill>
         <p:spPr>
@@ -6444,7 +6259,7 @@
           <p:nvPr/>
         </p:nvPicPr>
         <p:blipFill>
-          <a:blip xmlns:r="http://schemas.openxmlformats.org/officeDocument/2006/relationships" xmlns:a="http://schemas.openxmlformats.org/drawingml/2006/main" r:embed="R250743224b2047f7"/>
+          <a:blip xmlns:r="http://schemas.openxmlformats.org/officeDocument/2006/relationships" xmlns:a="http://schemas.openxmlformats.org/drawingml/2006/main" r:embed="Rad2d3dd8df354e80"/>
           <a:stretch xmlns:a="http://schemas.openxmlformats.org/drawingml/2006/main"/>
         </p:blipFill>
         <p:spPr>
@@ -6524,7 +6339,7 @@
           <p:nvPr/>
         </p:nvPicPr>
         <p:blipFill>
-          <a:blip xmlns:r="http://schemas.openxmlformats.org/officeDocument/2006/relationships" xmlns:a="http://schemas.openxmlformats.org/drawingml/2006/main" r:embed="R933dc57717904d2c"/>
+          <a:blip xmlns:r="http://schemas.openxmlformats.org/officeDocument/2006/relationships" xmlns:a="http://schemas.openxmlformats.org/drawingml/2006/main" r:embed="R296a475ba8e44bcc"/>
           <a:stretch xmlns:a="http://schemas.openxmlformats.org/drawingml/2006/main"/>
         </p:blipFill>
         <p:spPr>
@@ -6969,7 +6784,7 @@
                 <a:ea typeface="Arial"/>
                 <a:cs typeface="Arial"/>
               </a:rPr>
-              <a:t>1 = G      2 = S      3 = I</a:t>
+              <a:t>Good: 1      Service: 2      Idea: 3</a:t>
             </a:r>
           </a:p>
         </p:txBody>
@@ -7041,7 +6856,7 @@
           <p:nvPr/>
         </p:nvPicPr>
         <p:blipFill>
-          <a:blip xmlns:r="http://schemas.openxmlformats.org/officeDocument/2006/relationships" xmlns:a="http://schemas.openxmlformats.org/drawingml/2006/main" r:embed="R4727cc7fe9094cb7"/>
+          <a:blip xmlns:r="http://schemas.openxmlformats.org/officeDocument/2006/relationships" xmlns:a="http://schemas.openxmlformats.org/drawingml/2006/main" r:embed="Rfaae20ea466c447b"/>
           <a:stretch xmlns:a="http://schemas.openxmlformats.org/drawingml/2006/main"/>
         </p:blipFill>
         <p:spPr>
@@ -7107,7 +6922,7 @@
                 <a:ea typeface="Arial"/>
                 <a:cs typeface="Arial"/>
               </a:rPr>
-              <a:t>G  A tangible item</a:t>
+              <a:t>1  A tangible item</a:t>
             </a:r>
           </a:p>
         </p:txBody>
@@ -7121,7 +6936,7 @@
           <p:nvPr/>
         </p:nvPicPr>
         <p:blipFill>
-          <a:blip xmlns:r="http://schemas.openxmlformats.org/officeDocument/2006/relationships" xmlns:a="http://schemas.openxmlformats.org/drawingml/2006/main" r:embed="R4c547c1409174bfe"/>
+          <a:blip xmlns:r="http://schemas.openxmlformats.org/officeDocument/2006/relationships" xmlns:a="http://schemas.openxmlformats.org/drawingml/2006/main" r:embed="Re676e1095ee642c3"/>
           <a:stretch xmlns:a="http://schemas.openxmlformats.org/drawingml/2006/main"/>
         </p:blipFill>
         <p:spPr>
@@ -7187,7 +7002,7 @@
                 <a:ea typeface="Arial"/>
                 <a:cs typeface="Arial"/>
               </a:rPr>
-              <a:t>S  A task for payment</a:t>
+              <a:t>2  A task for payment</a:t>
             </a:r>
           </a:p>
         </p:txBody>
@@ -7201,7 +7016,7 @@
           <p:nvPr/>
         </p:nvPicPr>
         <p:blipFill>
-          <a:blip xmlns:r="http://schemas.openxmlformats.org/officeDocument/2006/relationships" xmlns:a="http://schemas.openxmlformats.org/drawingml/2006/main" r:embed="R4da8b8d2dc034a01"/>
+          <a:blip xmlns:r="http://schemas.openxmlformats.org/officeDocument/2006/relationships" xmlns:a="http://schemas.openxmlformats.org/drawingml/2006/main" r:embed="R93a0b61c5b384e8d"/>
           <a:stretch xmlns:a="http://schemas.openxmlformats.org/drawingml/2006/main"/>
         </p:blipFill>
         <p:spPr>
@@ -7267,7 +7082,7 @@
                 <a:ea typeface="Arial"/>
                 <a:cs typeface="Arial"/>
               </a:rPr>
-              <a:t>I  A thought or opinion</a:t>
+              <a:t>3  A thought or opinion</a:t>
             </a:r>
           </a:p>
         </p:txBody>
@@ -7718,7 +7533,7 @@
           <p:nvPr/>
         </p:nvPicPr>
         <p:blipFill>
-          <a:blip xmlns:r="http://schemas.openxmlformats.org/officeDocument/2006/relationships" xmlns:a="http://schemas.openxmlformats.org/drawingml/2006/main" r:embed="R511f66ddcf1445aa"/>
+          <a:blip xmlns:r="http://schemas.openxmlformats.org/officeDocument/2006/relationships" xmlns:a="http://schemas.openxmlformats.org/drawingml/2006/main" r:embed="R0580c992e3044d99"/>
           <a:stretch xmlns:a="http://schemas.openxmlformats.org/drawingml/2006/main"/>
         </p:blipFill>
         <p:spPr>
@@ -7842,7 +7657,7 @@
                 <a:ea typeface="Arial"/>
                 <a:cs typeface="Arial"/>
               </a:rPr>
-              <a:t>Choose one scene. Name a P or function that could support it.</a:t>
+              <a:t>Good: tangible item. Service: paid task. Idea: thought or opinion.</a:t>
             </a:r>
           </a:p>
         </p:txBody>
@@ -7930,7 +7745,7 @@
                 <a:ea typeface="Arial"/>
                 <a:cs typeface="Arial"/>
               </a:rPr>
-              <a:t>NEXT: Notes → required reading → vocabulary/application</a:t>
+              <a:t>Different offerings. Different ways to meet a need.</a:t>
             </a:r>
           </a:p>
         </p:txBody>
@@ -8105,7 +7920,7 @@
                 <a:ea typeface="Arial"/>
                 <a:cs typeface="Arial"/>
               </a:rPr>
-              <a:t>MONDAY · NOTICE AND CHOOSE</a:t>
+              <a:t>OPTIONAL MONDAY CATCH-UP · CHOOSE</a:t>
             </a:r>
           </a:p>
         </p:txBody>
@@ -8221,7 +8036,7 @@
                 <a:ea typeface="Arial"/>
                 <a:cs typeface="Arial"/>
               </a:rPr>
-              <a:t>More than a place to buy food?</a:t>
+              <a:t>Who benefits when a bakery sells bread?</a:t>
             </a:r>
           </a:p>
         </p:txBody>
@@ -8279,7 +8094,7 @@
                 <a:ea typeface="Arial"/>
                 <a:cs typeface="Arial"/>
               </a:rPr>
-              <a:t>Imagine a neighborhood market near school.</a:t>
+              <a:t>A customer, a worker, and a community.</a:t>
             </a:r>
           </a:p>
         </p:txBody>
@@ -8337,7 +8152,7 @@
                 <a:ea typeface="Arial"/>
                 <a:cs typeface="Arial"/>
               </a:rPr>
-              <a:t>Which scenes show products for sale? Choose all that fit.</a:t>
+              <a:t>Besides the customer, who can benefit? Choose the numbers.</a:t>
             </a:r>
           </a:p>
         </p:txBody>
@@ -8351,8 +8166,11 @@
           <p:nvPr/>
         </p:nvPicPr>
         <p:blipFill>
-          <a:blip xmlns:r="http://schemas.openxmlformats.org/officeDocument/2006/relationships" xmlns:a="http://schemas.openxmlformats.org/drawingml/2006/main" r:embed="R7e8e650dbe324ebd"/>
-          <a:stretch xmlns:a="http://schemas.openxmlformats.org/drawingml/2006/main"/>
+          <a:blip xmlns:r="http://schemas.openxmlformats.org/officeDocument/2006/relationships" xmlns:a="http://schemas.openxmlformats.org/drawingml/2006/main" r:embed="R6b56bdc7f1104e9d"/>
+          <a:srcRect xmlns:a="http://schemas.openxmlformats.org/drawingml/2006/main" l="0" t="18754" r="0" b="18754"/>
+          <a:stretch xmlns:a="http://schemas.openxmlformats.org/drawingml/2006/main">
+            <a:fillRect l="0" t="0" r="0" b="0"/>
+          </a:stretch>
         </p:blipFill>
         <p:spPr>
           <a:xfrm xmlns:a="http://schemas.openxmlformats.org/drawingml/2006/main">
@@ -8417,7 +8235,7 @@
                 <a:ea typeface="Arial"/>
                 <a:cs typeface="Arial"/>
               </a:rPr>
-              <a:t>A  Food stall</a:t>
+              <a:t>1  Customer buys bread</a:t>
             </a:r>
           </a:p>
         </p:txBody>
@@ -8431,8 +8249,11 @@
           <p:nvPr/>
         </p:nvPicPr>
         <p:blipFill>
-          <a:blip xmlns:r="http://schemas.openxmlformats.org/officeDocument/2006/relationships" xmlns:a="http://schemas.openxmlformats.org/drawingml/2006/main" r:embed="R5a8c03f152e44f38"/>
-          <a:stretch xmlns:a="http://schemas.openxmlformats.org/drawingml/2006/main"/>
+          <a:blip xmlns:r="http://schemas.openxmlformats.org/officeDocument/2006/relationships" xmlns:a="http://schemas.openxmlformats.org/drawingml/2006/main" r:embed="Rdcb13b90066b473f"/>
+          <a:srcRect xmlns:a="http://schemas.openxmlformats.org/drawingml/2006/main" l="0" t="18754" r="0" b="18754"/>
+          <a:stretch xmlns:a="http://schemas.openxmlformats.org/drawingml/2006/main">
+            <a:fillRect l="0" t="0" r="0" b="0"/>
+          </a:stretch>
         </p:blipFill>
         <p:spPr>
           <a:xfrm xmlns:a="http://schemas.openxmlformats.org/drawingml/2006/main">
@@ -8497,7 +8318,7 @@
                 <a:ea typeface="Arial"/>
                 <a:cs typeface="Arial"/>
               </a:rPr>
-              <a:t>B  Paid bicycle repair</a:t>
+              <a:t>2  Worker earns pay</a:t>
             </a:r>
           </a:p>
         </p:txBody>
@@ -8511,8 +8332,11 @@
           <p:nvPr/>
         </p:nvPicPr>
         <p:blipFill>
-          <a:blip xmlns:r="http://schemas.openxmlformats.org/officeDocument/2006/relationships" xmlns:a="http://schemas.openxmlformats.org/drawingml/2006/main" r:embed="Rf0ea95735e50422b"/>
-          <a:stretch xmlns:a="http://schemas.openxmlformats.org/drawingml/2006/main"/>
+          <a:blip xmlns:r="http://schemas.openxmlformats.org/officeDocument/2006/relationships" xmlns:a="http://schemas.openxmlformats.org/drawingml/2006/main" r:embed="R8e0b9cada6564b59"/>
+          <a:srcRect xmlns:a="http://schemas.openxmlformats.org/drawingml/2006/main" l="0" t="18754" r="0" b="18754"/>
+          <a:stretch xmlns:a="http://schemas.openxmlformats.org/drawingml/2006/main">
+            <a:fillRect l="0" t="0" r="0" b="0"/>
+          </a:stretch>
         </p:blipFill>
         <p:spPr>
           <a:xfrm xmlns:a="http://schemas.openxmlformats.org/drawingml/2006/main">
@@ -8577,7 +8401,7 @@
                 <a:ea typeface="Arial"/>
                 <a:cs typeface="Arial"/>
               </a:rPr>
-              <a:t>C  Recycling message</a:t>
+              <a:t>3  Community public services</a:t>
             </a:r>
           </a:p>
         </p:txBody>
@@ -8840,7 +8664,7 @@
                 <a:ea typeface="Arial"/>
                 <a:cs typeface="Arial"/>
               </a:rPr>
-              <a:t>MONDAY · CHECK</a:t>
+              <a:t>OPTIONAL MONDAY CATCH-UP · CHECK</a:t>
             </a:r>
           </a:p>
         </p:txBody>
@@ -8956,7 +8780,7 @@
                 <a:ea typeface="Arial"/>
                 <a:cs typeface="Arial"/>
               </a:rPr>
-              <a:t>A and B show products for sale</a:t>
+              <a:t>2  Workers       3  Community</a:t>
             </a:r>
           </a:p>
         </p:txBody>
@@ -9028,8 +8852,11 @@
           <p:nvPr/>
         </p:nvPicPr>
         <p:blipFill>
-          <a:blip xmlns:r="http://schemas.openxmlformats.org/officeDocument/2006/relationships" xmlns:a="http://schemas.openxmlformats.org/drawingml/2006/main" r:embed="R9213b1ccccdd4f21"/>
-          <a:stretch xmlns:a="http://schemas.openxmlformats.org/drawingml/2006/main"/>
+          <a:blip xmlns:r="http://schemas.openxmlformats.org/officeDocument/2006/relationships" xmlns:a="http://schemas.openxmlformats.org/drawingml/2006/main" r:embed="R0d19ea0ff46f4d3c"/>
+          <a:srcRect xmlns:a="http://schemas.openxmlformats.org/drawingml/2006/main" l="0" t="21115" r="0" b="21115"/>
+          <a:stretch xmlns:a="http://schemas.openxmlformats.org/drawingml/2006/main">
+            <a:fillRect l="0" t="0" r="0" b="0"/>
+          </a:stretch>
         </p:blipFill>
         <p:spPr>
           <a:xfrm xmlns:a="http://schemas.openxmlformats.org/drawingml/2006/main">
@@ -9094,7 +8921,7 @@
                 <a:ea typeface="Arial"/>
                 <a:cs typeface="Arial"/>
               </a:rPr>
-              <a:t>A  Goods meet needs/wants</a:t>
+              <a:t>1  Products meet needs</a:t>
             </a:r>
           </a:p>
         </p:txBody>
@@ -9108,8 +8935,11 @@
           <p:nvPr/>
         </p:nvPicPr>
         <p:blipFill>
-          <a:blip xmlns:r="http://schemas.openxmlformats.org/officeDocument/2006/relationships" xmlns:a="http://schemas.openxmlformats.org/drawingml/2006/main" r:embed="R74497aa01cfa43fd"/>
-          <a:stretch xmlns:a="http://schemas.openxmlformats.org/drawingml/2006/main"/>
+          <a:blip xmlns:r="http://schemas.openxmlformats.org/officeDocument/2006/relationships" xmlns:a="http://schemas.openxmlformats.org/drawingml/2006/main" r:embed="Ra1dcde0f81584510"/>
+          <a:srcRect xmlns:a="http://schemas.openxmlformats.org/drawingml/2006/main" l="0" t="21115" r="0" b="21115"/>
+          <a:stretch xmlns:a="http://schemas.openxmlformats.org/drawingml/2006/main">
+            <a:fillRect l="0" t="0" r="0" b="0"/>
+          </a:stretch>
         </p:blipFill>
         <p:spPr>
           <a:xfrm xmlns:a="http://schemas.openxmlformats.org/drawingml/2006/main">
@@ -9174,7 +9004,7 @@
                 <a:ea typeface="Arial"/>
                 <a:cs typeface="Arial"/>
               </a:rPr>
-              <a:t>B  Services meet needs/wants</a:t>
+              <a:t>2  Jobs provide income</a:t>
             </a:r>
           </a:p>
         </p:txBody>
@@ -9188,8 +9018,11 @@
           <p:nvPr/>
         </p:nvPicPr>
         <p:blipFill>
-          <a:blip xmlns:r="http://schemas.openxmlformats.org/officeDocument/2006/relationships" xmlns:a="http://schemas.openxmlformats.org/drawingml/2006/main" r:embed="R56f06e273e264e8d"/>
-          <a:stretch xmlns:a="http://schemas.openxmlformats.org/drawingml/2006/main"/>
+          <a:blip xmlns:r="http://schemas.openxmlformats.org/officeDocument/2006/relationships" xmlns:a="http://schemas.openxmlformats.org/drawingml/2006/main" r:embed="R86e6a13518b3491d"/>
+          <a:srcRect xmlns:a="http://schemas.openxmlformats.org/drawingml/2006/main" l="0" t="21115" r="0" b="21115"/>
+          <a:stretch xmlns:a="http://schemas.openxmlformats.org/drawingml/2006/main">
+            <a:fillRect l="0" t="0" r="0" b="0"/>
+          </a:stretch>
         </p:blipFill>
         <p:spPr>
           <a:xfrm xmlns:a="http://schemas.openxmlformats.org/drawingml/2006/main">
@@ -9254,7 +9087,7 @@
                 <a:ea typeface="Arial"/>
                 <a:cs typeface="Arial"/>
               </a:rPr>
-              <a:t>C  A community idea</a:t>
+              <a:t>3  Taxes help fund services</a:t>
             </a:r>
           </a:p>
         </p:txBody>
@@ -9342,7 +9175,7 @@
                 <a:ea typeface="Arial"/>
                 <a:cs typeface="Arial"/>
               </a:rPr>
-              <a:t>Businesses provide products, create markets, and support economic activity.</a:t>
+              <a:t>Business activity can support jobs and public services.</a:t>
             </a:r>
           </a:p>
         </p:txBody>
@@ -9517,7 +9350,7 @@
                 <a:ea typeface="Arial"/>
                 <a:cs typeface="Arial"/>
               </a:rPr>
-              <a:t>MONDAY · CONNECT</a:t>
+              <a:t>OPTIONAL MONDAY CATCH-UP · CONNECT</a:t>
             </a:r>
           </a:p>
         </p:txBody>
@@ -9705,8 +9538,11 @@
           <p:nvPr/>
         </p:nvPicPr>
         <p:blipFill>
-          <a:blip xmlns:r="http://schemas.openxmlformats.org/officeDocument/2006/relationships" xmlns:a="http://schemas.openxmlformats.org/drawingml/2006/main" r:embed="R043d71fabe924c4d"/>
-          <a:stretch xmlns:a="http://schemas.openxmlformats.org/drawingml/2006/main"/>
+          <a:blip xmlns:r="http://schemas.openxmlformats.org/officeDocument/2006/relationships" xmlns:a="http://schemas.openxmlformats.org/drawingml/2006/main" r:embed="Raba2e9bd337145b1"/>
+          <a:srcRect xmlns:a="http://schemas.openxmlformats.org/drawingml/2006/main" l="0" t="21318" r="0" b="21318"/>
+          <a:stretch xmlns:a="http://schemas.openxmlformats.org/drawingml/2006/main">
+            <a:fillRect l="0" t="0" r="0" b="0"/>
+          </a:stretch>
         </p:blipFill>
         <p:spPr>
           <a:xfrm xmlns:a="http://schemas.openxmlformats.org/drawingml/2006/main">
@@ -10280,7 +10116,7 @@
           <p:nvPr/>
         </p:nvPicPr>
         <p:blipFill>
-          <a:blip xmlns:r="http://schemas.openxmlformats.org/officeDocument/2006/relationships" xmlns:a="http://schemas.openxmlformats.org/drawingml/2006/main" r:embed="R20bce5f5de444a95"/>
+          <a:blip xmlns:r="http://schemas.openxmlformats.org/officeDocument/2006/relationships" xmlns:a="http://schemas.openxmlformats.org/drawingml/2006/main" r:embed="R0c9b8020b0b94deb"/>
           <a:stretch xmlns:a="http://schemas.openxmlformats.org/drawingml/2006/main"/>
         </p:blipFill>
         <p:spPr>
@@ -10360,7 +10196,7 @@
           <p:nvPr/>
         </p:nvPicPr>
         <p:blipFill>
-          <a:blip xmlns:r="http://schemas.openxmlformats.org/officeDocument/2006/relationships" xmlns:a="http://schemas.openxmlformats.org/drawingml/2006/main" r:embed="Rf3da00eb34c045ea"/>
+          <a:blip xmlns:r="http://schemas.openxmlformats.org/officeDocument/2006/relationships" xmlns:a="http://schemas.openxmlformats.org/drawingml/2006/main" r:embed="Re5f2d04696a94395"/>
           <a:stretch xmlns:a="http://schemas.openxmlformats.org/drawingml/2006/main"/>
         </p:blipFill>
         <p:spPr>
@@ -10440,7 +10276,7 @@
           <p:nvPr/>
         </p:nvPicPr>
         <p:blipFill>
-          <a:blip xmlns:r="http://schemas.openxmlformats.org/officeDocument/2006/relationships" xmlns:a="http://schemas.openxmlformats.org/drawingml/2006/main" r:embed="Rd26cda1951b64111"/>
+          <a:blip xmlns:r="http://schemas.openxmlformats.org/officeDocument/2006/relationships" xmlns:a="http://schemas.openxmlformats.org/drawingml/2006/main" r:embed="R3f6ce5f990d440b1"/>
           <a:stretch xmlns:a="http://schemas.openxmlformats.org/drawingml/2006/main"/>
         </p:blipFill>
         <p:spPr>
@@ -10957,7 +10793,7 @@
           <p:nvPr/>
         </p:nvPicPr>
         <p:blipFill>
-          <a:blip xmlns:r="http://schemas.openxmlformats.org/officeDocument/2006/relationships" xmlns:a="http://schemas.openxmlformats.org/drawingml/2006/main" r:embed="R743c80c62df54145"/>
+          <a:blip xmlns:r="http://schemas.openxmlformats.org/officeDocument/2006/relationships" xmlns:a="http://schemas.openxmlformats.org/drawingml/2006/main" r:embed="R0ba69026be0f4a6d"/>
           <a:stretch xmlns:a="http://schemas.openxmlformats.org/drawingml/2006/main"/>
         </p:blipFill>
         <p:spPr>
@@ -11590,7 +11426,7 @@
           <p:nvPr/>
         </p:nvPicPr>
         <p:blipFill>
-          <a:blip xmlns:r="http://schemas.openxmlformats.org/officeDocument/2006/relationships" xmlns:a="http://schemas.openxmlformats.org/drawingml/2006/main" r:embed="R9c6db4158e04488b"/>
+          <a:blip xmlns:r="http://schemas.openxmlformats.org/officeDocument/2006/relationships" xmlns:a="http://schemas.openxmlformats.org/drawingml/2006/main" r:embed="R6eee44d9190e4010"/>
           <a:stretch xmlns:a="http://schemas.openxmlformats.org/drawingml/2006/main"/>
         </p:blipFill>
         <p:spPr>
@@ -11670,7 +11506,7 @@
           <p:nvPr/>
         </p:nvPicPr>
         <p:blipFill>
-          <a:blip xmlns:r="http://schemas.openxmlformats.org/officeDocument/2006/relationships" xmlns:a="http://schemas.openxmlformats.org/drawingml/2006/main" r:embed="Rd4fd1dfd08b9463a"/>
+          <a:blip xmlns:r="http://schemas.openxmlformats.org/officeDocument/2006/relationships" xmlns:a="http://schemas.openxmlformats.org/drawingml/2006/main" r:embed="R482e1877c0ff4790"/>
           <a:stretch xmlns:a="http://schemas.openxmlformats.org/drawingml/2006/main"/>
         </p:blipFill>
         <p:spPr>
@@ -11750,7 +11586,7 @@
           <p:nvPr/>
         </p:nvPicPr>
         <p:blipFill>
-          <a:blip xmlns:r="http://schemas.openxmlformats.org/officeDocument/2006/relationships" xmlns:a="http://schemas.openxmlformats.org/drawingml/2006/main" r:embed="R74b21327e3474dd0"/>
+          <a:blip xmlns:r="http://schemas.openxmlformats.org/officeDocument/2006/relationships" xmlns:a="http://schemas.openxmlformats.org/drawingml/2006/main" r:embed="Rc38a4182540b4d42"/>
           <a:stretch xmlns:a="http://schemas.openxmlformats.org/drawingml/2006/main"/>
         </p:blipFill>
         <p:spPr>
@@ -12267,7 +12103,7 @@
           <p:nvPr/>
         </p:nvPicPr>
         <p:blipFill>
-          <a:blip xmlns:r="http://schemas.openxmlformats.org/officeDocument/2006/relationships" xmlns:a="http://schemas.openxmlformats.org/drawingml/2006/main" r:embed="Rb18a364c1ff14d81"/>
+          <a:blip xmlns:r="http://schemas.openxmlformats.org/officeDocument/2006/relationships" xmlns:a="http://schemas.openxmlformats.org/drawingml/2006/main" r:embed="R15afd763404d4558"/>
           <a:stretch xmlns:a="http://schemas.openxmlformats.org/drawingml/2006/main"/>
         </p:blipFill>
         <p:spPr>
@@ -12347,7 +12183,7 @@
           <p:nvPr/>
         </p:nvPicPr>
         <p:blipFill>
-          <a:blip xmlns:r="http://schemas.openxmlformats.org/officeDocument/2006/relationships" xmlns:a="http://schemas.openxmlformats.org/drawingml/2006/main" r:embed="R6a52ac9a34734d93"/>
+          <a:blip xmlns:r="http://schemas.openxmlformats.org/officeDocument/2006/relationships" xmlns:a="http://schemas.openxmlformats.org/drawingml/2006/main" r:embed="R39e00425bb944c45"/>
           <a:stretch xmlns:a="http://schemas.openxmlformats.org/drawingml/2006/main"/>
         </p:blipFill>
         <p:spPr>
@@ -12427,7 +12263,7 @@
           <p:nvPr/>
         </p:nvPicPr>
         <p:blipFill>
-          <a:blip xmlns:r="http://schemas.openxmlformats.org/officeDocument/2006/relationships" xmlns:a="http://schemas.openxmlformats.org/drawingml/2006/main" r:embed="Rf50261c9705c4216"/>
+          <a:blip xmlns:r="http://schemas.openxmlformats.org/officeDocument/2006/relationships" xmlns:a="http://schemas.openxmlformats.org/drawingml/2006/main" r:embed="R9bc2e2d72e8346c1"/>
           <a:stretch xmlns:a="http://schemas.openxmlformats.org/drawingml/2006/main"/>
         </p:blipFill>
         <p:spPr>
@@ -12944,7 +12780,7 @@
           <p:nvPr/>
         </p:nvPicPr>
         <p:blipFill>
-          <a:blip xmlns:r="http://schemas.openxmlformats.org/officeDocument/2006/relationships" xmlns:a="http://schemas.openxmlformats.org/drawingml/2006/main" r:embed="R56133bcfea0b4dfd"/>
+          <a:blip xmlns:r="http://schemas.openxmlformats.org/officeDocument/2006/relationships" xmlns:a="http://schemas.openxmlformats.org/drawingml/2006/main" r:embed="Rb91a9250622a4da7"/>
           <a:stretch xmlns:a="http://schemas.openxmlformats.org/drawingml/2006/main"/>
         </p:blipFill>
         <p:spPr>
@@ -13570,20 +13406,20 @@
       </p:sp>
       <p:pic>
         <p:nvPicPr>
-          <p:cNvPr id="22" name=""/>
+          <p:cNvPr id="24" name=""/>
           <p:cNvPicPr>
             <a:picLocks xmlns:a="http://schemas.openxmlformats.org/drawingml/2006/main" noChangeAspect="1"/>
           </p:cNvPicPr>
           <p:nvPr/>
         </p:nvPicPr>
         <p:blipFill>
-          <a:blip xmlns:r="http://schemas.openxmlformats.org/officeDocument/2006/relationships" xmlns:a="http://schemas.openxmlformats.org/drawingml/2006/main" r:embed="R21459aef2e114fe8"/>
+          <a:blip xmlns:r="http://schemas.openxmlformats.org/officeDocument/2006/relationships" xmlns:a="http://schemas.openxmlformats.org/drawingml/2006/main" r:embed="R5a2cbfd3a8324861"/>
           <a:stretch xmlns:a="http://schemas.openxmlformats.org/drawingml/2006/main"/>
         </p:blipFill>
         <p:spPr>
           <a:xfrm xmlns:a="http://schemas.openxmlformats.org/drawingml/2006/main">
-            <a:off x="609600" y="2571750"/>
-            <a:ext cx="5143500" cy="2876550"/>
+            <a:off x="609600" y="2524125"/>
+            <a:ext cx="3409950" cy="2143125"/>
           </a:xfrm>
           <a:prstGeom xmlns:a="http://schemas.openxmlformats.org/drawingml/2006/main" prst="rect">
             <a:avLst/>
@@ -13606,36 +13442,36 @@
         </p:nvSpPr>
         <p:spPr>
           <a:xfrm xmlns:a="http://schemas.openxmlformats.org/drawingml/2006/main">
-            <a:off x="6191250" y="2676525"/>
-            <a:ext cx="5238750" cy="809625"/>
-          </a:xfrm>
-          <a:prstGeom xmlns:a="http://schemas.openxmlformats.org/drawingml/2006/main" prst="rect">
-            <a:avLst/>
-          </a:prstGeom>
-          <a:noFill xmlns:a="http://schemas.openxmlformats.org/drawingml/2006/main"/>
-          <a:ln xmlns:a="http://schemas.openxmlformats.org/drawingml/2006/main" w="0">
-            <a:noFill/>
-          </a:ln>
-        </p:spPr>
-        <p:txBody>
-          <a:bodyPr xmlns:a="http://schemas.openxmlformats.org/drawingml/2006/main" anchor="ctr">
-            <a:noAutofit/>
-          </a:bodyPr>
-          <a:lstStyle xmlns:a="http://schemas.openxmlformats.org/drawingml/2006/main"/>
-          <a:p xmlns:a="http://schemas.openxmlformats.org/drawingml/2006/main">
-            <a:pPr>
-              <a:buNone/>
-              <a:defRPr sz="2325" b="1">
-                <a:solidFill>
-                  <a:srgbClr val="17334D"/>
-                </a:solidFill>
-                <a:latin typeface="Arial"/>
-                <a:ea typeface="Arial"/>
-                <a:cs typeface="Arial"/>
-              </a:defRPr>
-            </a:pPr>
-            <a:r>
-              <a:rPr sz="2325" b="1">
+            <a:off x="609600" y="4724400"/>
+            <a:ext cx="3409950" cy="666750"/>
+          </a:xfrm>
+          <a:prstGeom xmlns:a="http://schemas.openxmlformats.org/drawingml/2006/main" prst="rect">
+            <a:avLst/>
+          </a:prstGeom>
+          <a:noFill xmlns:a="http://schemas.openxmlformats.org/drawingml/2006/main"/>
+          <a:ln xmlns:a="http://schemas.openxmlformats.org/drawingml/2006/main" w="0">
+            <a:noFill/>
+          </a:ln>
+        </p:spPr>
+        <p:txBody>
+          <a:bodyPr xmlns:a="http://schemas.openxmlformats.org/drawingml/2006/main" anchor="ctr">
+            <a:noAutofit/>
+          </a:bodyPr>
+          <a:lstStyle xmlns:a="http://schemas.openxmlformats.org/drawingml/2006/main"/>
+          <a:p xmlns:a="http://schemas.openxmlformats.org/drawingml/2006/main">
+            <a:pPr>
+              <a:buNone/>
+              <a:defRPr sz="1875" b="1">
+                <a:solidFill>
+                  <a:srgbClr val="17334D"/>
+                </a:solidFill>
+                <a:latin typeface="Arial"/>
+                <a:ea typeface="Arial"/>
+                <a:cs typeface="Arial"/>
+              </a:defRPr>
+            </a:pPr>
+            <a:r>
+              <a:rPr sz="1875" b="1">
                 <a:solidFill>
                   <a:srgbClr val="17334D"/>
                 </a:solidFill>
@@ -13664,36 +13500,36 @@
         </p:nvSpPr>
         <p:spPr>
           <a:xfrm xmlns:a="http://schemas.openxmlformats.org/drawingml/2006/main">
-            <a:off x="6191250" y="3638550"/>
-            <a:ext cx="5238750" cy="809625"/>
-          </a:xfrm>
-          <a:prstGeom xmlns:a="http://schemas.openxmlformats.org/drawingml/2006/main" prst="rect">
-            <a:avLst/>
-          </a:prstGeom>
-          <a:noFill xmlns:a="http://schemas.openxmlformats.org/drawingml/2006/main"/>
-          <a:ln xmlns:a="http://schemas.openxmlformats.org/drawingml/2006/main" w="0">
-            <a:noFill/>
-          </a:ln>
-        </p:spPr>
-        <p:txBody>
-          <a:bodyPr xmlns:a="http://schemas.openxmlformats.org/drawingml/2006/main" anchor="ctr">
-            <a:noAutofit/>
-          </a:bodyPr>
-          <a:lstStyle xmlns:a="http://schemas.openxmlformats.org/drawingml/2006/main"/>
-          <a:p xmlns:a="http://schemas.openxmlformats.org/drawingml/2006/main">
-            <a:pPr>
-              <a:buNone/>
-              <a:defRPr sz="2325" b="1">
-                <a:solidFill>
-                  <a:srgbClr val="17334D"/>
-                </a:solidFill>
-                <a:latin typeface="Arial"/>
-                <a:ea typeface="Arial"/>
-                <a:cs typeface="Arial"/>
-              </a:defRPr>
-            </a:pPr>
-            <a:r>
-              <a:rPr sz="2325" b="1">
+            <a:off x="4391025" y="5067300"/>
+            <a:ext cx="3409950" cy="666750"/>
+          </a:xfrm>
+          <a:prstGeom xmlns:a="http://schemas.openxmlformats.org/drawingml/2006/main" prst="rect">
+            <a:avLst/>
+          </a:prstGeom>
+          <a:noFill xmlns:a="http://schemas.openxmlformats.org/drawingml/2006/main"/>
+          <a:ln xmlns:a="http://schemas.openxmlformats.org/drawingml/2006/main" w="0">
+            <a:noFill/>
+          </a:ln>
+        </p:spPr>
+        <p:txBody>
+          <a:bodyPr xmlns:a="http://schemas.openxmlformats.org/drawingml/2006/main" anchor="ctr">
+            <a:noAutofit/>
+          </a:bodyPr>
+          <a:lstStyle xmlns:a="http://schemas.openxmlformats.org/drawingml/2006/main"/>
+          <a:p xmlns:a="http://schemas.openxmlformats.org/drawingml/2006/main">
+            <a:pPr>
+              <a:buNone/>
+              <a:defRPr sz="1875" b="1">
+                <a:solidFill>
+                  <a:srgbClr val="17334D"/>
+                </a:solidFill>
+                <a:latin typeface="Arial"/>
+                <a:ea typeface="Arial"/>
+                <a:cs typeface="Arial"/>
+              </a:defRPr>
+            </a:pPr>
+            <a:r>
+              <a:rPr sz="1875" b="1">
                 <a:solidFill>
                   <a:srgbClr val="17334D"/>
                 </a:solidFill>
@@ -13722,36 +13558,36 @@
         </p:nvSpPr>
         <p:spPr>
           <a:xfrm xmlns:a="http://schemas.openxmlformats.org/drawingml/2006/main">
-            <a:off x="6191250" y="4600575"/>
-            <a:ext cx="5238750" cy="809625"/>
-          </a:xfrm>
-          <a:prstGeom xmlns:a="http://schemas.openxmlformats.org/drawingml/2006/main" prst="rect">
-            <a:avLst/>
-          </a:prstGeom>
-          <a:noFill xmlns:a="http://schemas.openxmlformats.org/drawingml/2006/main"/>
-          <a:ln xmlns:a="http://schemas.openxmlformats.org/drawingml/2006/main" w="0">
-            <a:noFill/>
-          </a:ln>
-        </p:spPr>
-        <p:txBody>
-          <a:bodyPr xmlns:a="http://schemas.openxmlformats.org/drawingml/2006/main" anchor="ctr">
-            <a:noAutofit/>
-          </a:bodyPr>
-          <a:lstStyle xmlns:a="http://schemas.openxmlformats.org/drawingml/2006/main"/>
-          <a:p xmlns:a="http://schemas.openxmlformats.org/drawingml/2006/main">
-            <a:pPr>
-              <a:buNone/>
-              <a:defRPr sz="2325" b="1">
-                <a:solidFill>
-                  <a:srgbClr val="17334D"/>
-                </a:solidFill>
-                <a:latin typeface="Arial"/>
-                <a:ea typeface="Arial"/>
-                <a:cs typeface="Arial"/>
-              </a:defRPr>
-            </a:pPr>
-            <a:r>
-              <a:rPr sz="2325" b="1">
+            <a:off x="8172450" y="4724400"/>
+            <a:ext cx="3409950" cy="666750"/>
+          </a:xfrm>
+          <a:prstGeom xmlns:a="http://schemas.openxmlformats.org/drawingml/2006/main" prst="rect">
+            <a:avLst/>
+          </a:prstGeom>
+          <a:noFill xmlns:a="http://schemas.openxmlformats.org/drawingml/2006/main"/>
+          <a:ln xmlns:a="http://schemas.openxmlformats.org/drawingml/2006/main" w="0">
+            <a:noFill/>
+          </a:ln>
+        </p:spPr>
+        <p:txBody>
+          <a:bodyPr xmlns:a="http://schemas.openxmlformats.org/drawingml/2006/main" anchor="ctr">
+            <a:noAutofit/>
+          </a:bodyPr>
+          <a:lstStyle xmlns:a="http://schemas.openxmlformats.org/drawingml/2006/main"/>
+          <a:p xmlns:a="http://schemas.openxmlformats.org/drawingml/2006/main">
+            <a:pPr>
+              <a:buNone/>
+              <a:defRPr sz="1875" b="1">
+                <a:solidFill>
+                  <a:srgbClr val="17334D"/>
+                </a:solidFill>
+                <a:latin typeface="Arial"/>
+                <a:ea typeface="Arial"/>
+                <a:cs typeface="Arial"/>
+              </a:defRPr>
+            </a:pPr>
+            <a:r>
+              <a:rPr sz="1875" b="1">
                 <a:solidFill>
                   <a:srgbClr val="17334D"/>
                 </a:solidFill>
@@ -13910,6 +13746,50 @@
           </a:p>
         </p:txBody>
       </p:sp>
+      <p:pic>
+        <p:nvPicPr>
+          <p:cNvPr id="31" name=""/>
+          <p:cNvPicPr>
+            <a:picLocks xmlns:a="http://schemas.openxmlformats.org/drawingml/2006/main" noChangeAspect="1"/>
+          </p:cNvPicPr>
+          <p:nvPr/>
+        </p:nvPicPr>
+        <p:blipFill>
+          <a:blip xmlns:r="http://schemas.openxmlformats.org/officeDocument/2006/relationships" xmlns:a="http://schemas.openxmlformats.org/drawingml/2006/main" r:embed="Rf017bad760b84b88"/>
+          <a:stretch xmlns:a="http://schemas.openxmlformats.org/drawingml/2006/main"/>
+        </p:blipFill>
+        <p:spPr>
+          <a:xfrm xmlns:a="http://schemas.openxmlformats.org/drawingml/2006/main">
+            <a:off x="4391025" y="2867025"/>
+            <a:ext cx="3409950" cy="2143125"/>
+          </a:xfrm>
+          <a:prstGeom xmlns:a="http://schemas.openxmlformats.org/drawingml/2006/main" prst="rect">
+            <a:avLst/>
+          </a:prstGeom>
+        </p:spPr>
+      </p:pic>
+      <p:pic>
+        <p:nvPicPr>
+          <p:cNvPr id="32" name=""/>
+          <p:cNvPicPr>
+            <a:picLocks xmlns:a="http://schemas.openxmlformats.org/drawingml/2006/main" noChangeAspect="1"/>
+          </p:cNvPicPr>
+          <p:nvPr/>
+        </p:nvPicPr>
+        <p:blipFill>
+          <a:blip xmlns:r="http://schemas.openxmlformats.org/officeDocument/2006/relationships" xmlns:a="http://schemas.openxmlformats.org/drawingml/2006/main" r:embed="Ra17a9434d98e463c"/>
+          <a:stretch xmlns:a="http://schemas.openxmlformats.org/drawingml/2006/main"/>
+        </p:blipFill>
+        <p:spPr>
+          <a:xfrm xmlns:a="http://schemas.openxmlformats.org/drawingml/2006/main">
+            <a:off x="8172450" y="2524125"/>
+            <a:ext cx="3409950" cy="2143125"/>
+          </a:xfrm>
+          <a:prstGeom xmlns:a="http://schemas.openxmlformats.org/drawingml/2006/main" prst="rect">
+            <a:avLst/>
+          </a:prstGeom>
+        </p:spPr>
+      </p:pic>
     </p:spTree>
     <p:extLst>
       <p:ext uri="{BB962C8B-B14F-4D97-AF65-F5344CB8AC3E}">
@@ -14203,20 +14083,20 @@
       </p:sp>
       <p:pic>
         <p:nvPicPr>
-          <p:cNvPr id="19" name=""/>
+          <p:cNvPr id="22" name=""/>
           <p:cNvPicPr>
             <a:picLocks xmlns:a="http://schemas.openxmlformats.org/drawingml/2006/main" noChangeAspect="1"/>
           </p:cNvPicPr>
           <p:nvPr/>
         </p:nvPicPr>
         <p:blipFill>
-          <a:blip xmlns:r="http://schemas.openxmlformats.org/officeDocument/2006/relationships" xmlns:a="http://schemas.openxmlformats.org/drawingml/2006/main" r:embed="R3ff628eefc994dd4"/>
+          <a:blip xmlns:r="http://schemas.openxmlformats.org/officeDocument/2006/relationships" xmlns:a="http://schemas.openxmlformats.org/drawingml/2006/main" r:embed="R014c9c240b08491f"/>
           <a:stretch xmlns:a="http://schemas.openxmlformats.org/drawingml/2006/main"/>
         </p:blipFill>
         <p:spPr>
           <a:xfrm xmlns:a="http://schemas.openxmlformats.org/drawingml/2006/main">
             <a:off x="609600" y="2476500"/>
-            <a:ext cx="5143500" cy="2857500"/>
+            <a:ext cx="3409950" cy="1981200"/>
           </a:xfrm>
           <a:prstGeom xmlns:a="http://schemas.openxmlformats.org/drawingml/2006/main" prst="rect">
             <a:avLst/>
@@ -14239,44 +14119,44 @@
         </p:nvSpPr>
         <p:spPr>
           <a:xfrm xmlns:a="http://schemas.openxmlformats.org/drawingml/2006/main">
-            <a:off x="6191250" y="2571750"/>
-            <a:ext cx="5219700" cy="1238250"/>
-          </a:xfrm>
-          <a:prstGeom xmlns:a="http://schemas.openxmlformats.org/drawingml/2006/main" prst="rect">
-            <a:avLst/>
-          </a:prstGeom>
-          <a:noFill xmlns:a="http://schemas.openxmlformats.org/drawingml/2006/main"/>
-          <a:ln xmlns:a="http://schemas.openxmlformats.org/drawingml/2006/main" w="0">
-            <a:noFill/>
-          </a:ln>
-        </p:spPr>
-        <p:txBody>
-          <a:bodyPr xmlns:a="http://schemas.openxmlformats.org/drawingml/2006/main" anchor="ctr">
-            <a:noAutofit/>
-          </a:bodyPr>
-          <a:lstStyle xmlns:a="http://schemas.openxmlformats.org/drawingml/2006/main"/>
-          <a:p xmlns:a="http://schemas.openxmlformats.org/drawingml/2006/main">
-            <a:pPr>
-              <a:buNone/>
-              <a:defRPr sz="2550" b="1">
-                <a:solidFill>
-                  <a:srgbClr val="17334D"/>
-                </a:solidFill>
-                <a:latin typeface="Arial"/>
-                <a:ea typeface="Arial"/>
-                <a:cs typeface="Arial"/>
-              </a:defRPr>
-            </a:pPr>
-            <a:r>
-              <a:rPr sz="2550" b="1">
-                <a:solidFill>
-                  <a:srgbClr val="17334D"/>
-                </a:solidFill>
-                <a:latin typeface="Arial"/>
-                <a:ea typeface="Arial"/>
-                <a:cs typeface="Arial"/>
-              </a:rPr>
-              <a:t>Players, spectators, and people who are not interested can all answer.</a:t>
+            <a:off x="609600" y="4533900"/>
+            <a:ext cx="3409950" cy="666750"/>
+          </a:xfrm>
+          <a:prstGeom xmlns:a="http://schemas.openxmlformats.org/drawingml/2006/main" prst="rect">
+            <a:avLst/>
+          </a:prstGeom>
+          <a:noFill xmlns:a="http://schemas.openxmlformats.org/drawingml/2006/main"/>
+          <a:ln xmlns:a="http://schemas.openxmlformats.org/drawingml/2006/main" w="0">
+            <a:noFill/>
+          </a:ln>
+        </p:spPr>
+        <p:txBody>
+          <a:bodyPr xmlns:a="http://schemas.openxmlformats.org/drawingml/2006/main" anchor="ctr">
+            <a:noAutofit/>
+          </a:bodyPr>
+          <a:lstStyle xmlns:a="http://schemas.openxmlformats.org/drawingml/2006/main"/>
+          <a:p xmlns:a="http://schemas.openxmlformats.org/drawingml/2006/main">
+            <a:pPr>
+              <a:buNone/>
+              <a:defRPr sz="2025" b="1">
+                <a:solidFill>
+                  <a:srgbClr val="17334D"/>
+                </a:solidFill>
+                <a:latin typeface="Arial"/>
+                <a:ea typeface="Arial"/>
+                <a:cs typeface="Arial"/>
+              </a:defRPr>
+            </a:pPr>
+            <a:r>
+              <a:rPr sz="2025" b="1">
+                <a:solidFill>
+                  <a:srgbClr val="17334D"/>
+                </a:solidFill>
+                <a:latin typeface="Arial"/>
+                <a:ea typeface="Arial"/>
+                <a:cs typeface="Arial"/>
+              </a:rPr>
+              <a:t>A  Pushes agreement</a:t>
             </a:r>
           </a:p>
         </p:txBody>
@@ -14297,44 +14177,44 @@
         </p:nvSpPr>
         <p:spPr>
           <a:xfrm xmlns:a="http://schemas.openxmlformats.org/drawingml/2006/main">
-            <a:off x="6191250" y="4114800"/>
-            <a:ext cx="5219700" cy="952500"/>
-          </a:xfrm>
-          <a:prstGeom xmlns:a="http://schemas.openxmlformats.org/drawingml/2006/main" prst="rect">
-            <a:avLst/>
-          </a:prstGeom>
-          <a:noFill xmlns:a="http://schemas.openxmlformats.org/drawingml/2006/main"/>
-          <a:ln xmlns:a="http://schemas.openxmlformats.org/drawingml/2006/main" w="0">
-            <a:noFill/>
-          </a:ln>
-        </p:spPr>
-        <p:txBody>
-          <a:bodyPr xmlns:a="http://schemas.openxmlformats.org/drawingml/2006/main" anchor="ctr">
-            <a:noAutofit/>
-          </a:bodyPr>
-          <a:lstStyle xmlns:a="http://schemas.openxmlformats.org/drawingml/2006/main"/>
-          <a:p xmlns:a="http://schemas.openxmlformats.org/drawingml/2006/main">
-            <a:pPr>
-              <a:buNone/>
-              <a:defRPr sz="2325" b="0">
-                <a:solidFill>
-                  <a:srgbClr val="17334D"/>
-                </a:solidFill>
-                <a:latin typeface="Arial"/>
-                <a:ea typeface="Arial"/>
-                <a:cs typeface="Arial"/>
-              </a:defRPr>
-            </a:pPr>
-            <a:r>
-              <a:rPr sz="2325" b="0">
-                <a:solidFill>
-                  <a:srgbClr val="17334D"/>
-                </a:solidFill>
-                <a:latin typeface="Arial"/>
-                <a:ea typeface="Arial"/>
-                <a:cs typeface="Arial"/>
-              </a:rPr>
-              <a:t>The answer helps identify the target market.</a:t>
+            <a:off x="4391025" y="5010150"/>
+            <a:ext cx="3409950" cy="666750"/>
+          </a:xfrm>
+          <a:prstGeom xmlns:a="http://schemas.openxmlformats.org/drawingml/2006/main" prst="rect">
+            <a:avLst/>
+          </a:prstGeom>
+          <a:noFill xmlns:a="http://schemas.openxmlformats.org/drawingml/2006/main"/>
+          <a:ln xmlns:a="http://schemas.openxmlformats.org/drawingml/2006/main" w="0">
+            <a:noFill/>
+          </a:ln>
+        </p:spPr>
+        <p:txBody>
+          <a:bodyPr xmlns:a="http://schemas.openxmlformats.org/drawingml/2006/main" anchor="ctr">
+            <a:noAutofit/>
+          </a:bodyPr>
+          <a:lstStyle xmlns:a="http://schemas.openxmlformats.org/drawingml/2006/main"/>
+          <a:p xmlns:a="http://schemas.openxmlformats.org/drawingml/2006/main">
+            <a:pPr>
+              <a:buNone/>
+              <a:defRPr sz="2025" b="1">
+                <a:solidFill>
+                  <a:srgbClr val="17334D"/>
+                </a:solidFill>
+                <a:latin typeface="Arial"/>
+                <a:ea typeface="Arial"/>
+                <a:cs typeface="Arial"/>
+              </a:defRPr>
+            </a:pPr>
+            <a:r>
+              <a:rPr sz="2025" b="1">
+                <a:solidFill>
+                  <a:srgbClr val="17334D"/>
+                </a:solidFill>
+                <a:latin typeface="Arial"/>
+                <a:ea typeface="Arial"/>
+                <a:cs typeface="Arial"/>
+              </a:rPr>
+              <a:t>B  Welcomes different answers</a:t>
             </a:r>
           </a:p>
         </p:txBody>
@@ -14481,6 +14361,107 @@
                 <a:cs typeface="Arial"/>
               </a:rPr>
               <a:t>pp. 13–15 · SBTE 11–13     Point to the clue that supports your answer.     8</a:t>
+            </a:r>
+          </a:p>
+        </p:txBody>
+      </p:sp>
+      <p:pic>
+        <p:nvPicPr>
+          <p:cNvPr id="28" name=""/>
+          <p:cNvPicPr>
+            <a:picLocks xmlns:a="http://schemas.openxmlformats.org/drawingml/2006/main" noChangeAspect="1"/>
+          </p:cNvPicPr>
+          <p:nvPr/>
+        </p:nvPicPr>
+        <p:blipFill>
+          <a:blip xmlns:r="http://schemas.openxmlformats.org/officeDocument/2006/relationships" xmlns:a="http://schemas.openxmlformats.org/drawingml/2006/main" r:embed="Re2a34e5f8f0247e2"/>
+          <a:stretch xmlns:a="http://schemas.openxmlformats.org/drawingml/2006/main"/>
+        </p:blipFill>
+        <p:spPr>
+          <a:xfrm xmlns:a="http://schemas.openxmlformats.org/drawingml/2006/main">
+            <a:off x="4391025" y="2952750"/>
+            <a:ext cx="3409950" cy="1981200"/>
+          </a:xfrm>
+          <a:prstGeom xmlns:a="http://schemas.openxmlformats.org/drawingml/2006/main" prst="rect">
+            <a:avLst/>
+          </a:prstGeom>
+        </p:spPr>
+      </p:pic>
+      <p:pic>
+        <p:nvPicPr>
+          <p:cNvPr id="29" name=""/>
+          <p:cNvPicPr>
+            <a:picLocks xmlns:a="http://schemas.openxmlformats.org/drawingml/2006/main" noChangeAspect="1"/>
+          </p:cNvPicPr>
+          <p:nvPr/>
+        </p:nvPicPr>
+        <p:blipFill>
+          <a:blip xmlns:r="http://schemas.openxmlformats.org/officeDocument/2006/relationships" xmlns:a="http://schemas.openxmlformats.org/drawingml/2006/main" r:embed="R2d6f08c1e9724874"/>
+          <a:stretch xmlns:a="http://schemas.openxmlformats.org/drawingml/2006/main"/>
+        </p:blipFill>
+        <p:spPr>
+          <a:xfrm xmlns:a="http://schemas.openxmlformats.org/drawingml/2006/main">
+            <a:off x="8172450" y="2476500"/>
+            <a:ext cx="3409950" cy="1981200"/>
+          </a:xfrm>
+          <a:prstGeom xmlns:a="http://schemas.openxmlformats.org/drawingml/2006/main" prst="rect">
+            <a:avLst/>
+          </a:prstGeom>
+        </p:spPr>
+      </p:pic>
+      <p:sp>
+        <p:nvSpPr>
+          <p:cNvPr id="16" name="">
+            <a:extLst xmlns:a="http://schemas.openxmlformats.org/drawingml/2006/main">
+              <a:ext uri="{FF2B5EF4-FFF2-40B4-BE49-F238E27FC236}">
+                <a16:creationId xmlns:a16="http://schemas.microsoft.com/office/drawing/2014/main" id="{7042D1C3-E693-4FF7-8CE0-DA13E9527B15}"/>
+              </a:ext>
+            </a:extLst>
+          </p:cNvPr>
+          <p:cNvSpPr>
+            <a:spLocks xmlns:a="http://schemas.openxmlformats.org/drawingml/2006/main" noGrp="1"/>
+          </p:cNvSpPr>
+          <p:nvPr/>
+        </p:nvSpPr>
+        <p:spPr>
+          <a:xfrm xmlns:a="http://schemas.openxmlformats.org/drawingml/2006/main">
+            <a:off x="8172450" y="4533900"/>
+            <a:ext cx="3409950" cy="666750"/>
+          </a:xfrm>
+          <a:prstGeom xmlns:a="http://schemas.openxmlformats.org/drawingml/2006/main" prst="rect">
+            <a:avLst/>
+          </a:prstGeom>
+          <a:noFill xmlns:a="http://schemas.openxmlformats.org/drawingml/2006/main"/>
+          <a:ln xmlns:a="http://schemas.openxmlformats.org/drawingml/2006/main" w="0">
+            <a:noFill/>
+          </a:ln>
+        </p:spPr>
+        <p:txBody>
+          <a:bodyPr xmlns:a="http://schemas.openxmlformats.org/drawingml/2006/main" anchor="ctr">
+            <a:noAutofit/>
+          </a:bodyPr>
+          <a:lstStyle xmlns:a="http://schemas.openxmlformats.org/drawingml/2006/main"/>
+          <a:p xmlns:a="http://schemas.openxmlformats.org/drawingml/2006/main">
+            <a:pPr>
+              <a:defRPr sz="2025" b="1">
+                <a:solidFill>
+                  <a:srgbClr val="17334D"/>
+                </a:solidFill>
+                <a:latin typeface="Arial"/>
+                <a:ea typeface="Arial"/>
+                <a:cs typeface="Arial"/>
+              </a:defRPr>
+            </a:pPr>
+            <a:r>
+              <a:rPr sz="2025" b="1">
+                <a:solidFill>
+                  <a:srgbClr val="17334D"/>
+                </a:solidFill>
+                <a:latin typeface="Arial"/>
+                <a:ea typeface="Arial"/>
+                <a:cs typeface="Arial"/>
+              </a:rPr>
+              <a:t>C  Centers my preference</a:t>
             </a:r>
           </a:p>
         </p:txBody>
@@ -14785,7 +14766,7 @@
           <p:nvPr/>
         </p:nvPicPr>
         <p:blipFill>
-          <a:blip xmlns:r="http://schemas.openxmlformats.org/officeDocument/2006/relationships" xmlns:a="http://schemas.openxmlformats.org/drawingml/2006/main" r:embed="R9318d6c1f53a494d"/>
+          <a:blip xmlns:r="http://schemas.openxmlformats.org/officeDocument/2006/relationships" xmlns:a="http://schemas.openxmlformats.org/drawingml/2006/main" r:embed="Rab1efaa1fcdc415f"/>
           <a:stretch xmlns:a="http://schemas.openxmlformats.org/drawingml/2006/main"/>
         </p:blipFill>
         <p:spPr>

</xml_diff>

<commit_message>
Ground Tuesday and Thursday entries in concrete problems before terminology
</commit_message>
<xml_diff>
--- a/second-placement/planning/2026-09-21-to-25/2026-09-21-to-25-Entry-Routines-Visual-v3.pptx
+++ b/second-placement/planning/2026-09-21-to-25/2026-09-21-to-25-Entry-Routines-Visual-v3.pptx
@@ -2,30 +2,30 @@
 <file path=ppt/presentation.xml><?xml version="1.0" encoding="utf-8"?>
 <p:presentation xmlns:p="http://schemas.openxmlformats.org/presentationml/2006/main">
   <p:sldMasterIdLst>
-    <p:sldMasterId xmlns:r="http://schemas.openxmlformats.org/officeDocument/2006/relationships" id="2147483648" r:id="Ra1f25ed7525b4cd9"/>
+    <p:sldMasterId xmlns:r="http://schemas.openxmlformats.org/officeDocument/2006/relationships" id="2147483648" r:id="R4413b05bbcfd4a6f"/>
   </p:sldMasterIdLst>
   <p:notesMasterIdLst>
-    <p:notesMasterId xmlns:r="http://schemas.openxmlformats.org/officeDocument/2006/relationships" r:id="R60407ee572bd42a4"/>
+    <p:notesMasterId xmlns:r="http://schemas.openxmlformats.org/officeDocument/2006/relationships" r:id="R33b2a8981a894d07"/>
   </p:notesMasterIdLst>
   <p:sldIdLst>
-    <p:sldId xmlns:r="http://schemas.openxmlformats.org/officeDocument/2006/relationships" id="256" r:id="Rc76cb4d53ca347e5"/>
-    <p:sldId xmlns:r="http://schemas.openxmlformats.org/officeDocument/2006/relationships" id="257" r:id="R34dc33ad7f8c4428"/>
-    <p:sldId xmlns:r="http://schemas.openxmlformats.org/officeDocument/2006/relationships" id="258" r:id="Rccecd91ea9f242ed"/>
-    <p:sldId xmlns:r="http://schemas.openxmlformats.org/officeDocument/2006/relationships" id="259" r:id="Rb9e62f09cfe446e0"/>
-    <p:sldId xmlns:r="http://schemas.openxmlformats.org/officeDocument/2006/relationships" id="260" r:id="Rd2a7b763aab34911"/>
-    <p:sldId xmlns:r="http://schemas.openxmlformats.org/officeDocument/2006/relationships" id="261" r:id="R532111f0e5ea4220"/>
-    <p:sldId xmlns:r="http://schemas.openxmlformats.org/officeDocument/2006/relationships" id="262" r:id="R54ff8ffc644b4ef3"/>
-    <p:sldId xmlns:r="http://schemas.openxmlformats.org/officeDocument/2006/relationships" id="263" r:id="Ra74cfa9244c840c1"/>
-    <p:sldId xmlns:r="http://schemas.openxmlformats.org/officeDocument/2006/relationships" id="264" r:id="R80614cdfa23c480c"/>
-    <p:sldId xmlns:r="http://schemas.openxmlformats.org/officeDocument/2006/relationships" id="265" r:id="R5e2859f4aa164f98"/>
-    <p:sldId xmlns:r="http://schemas.openxmlformats.org/officeDocument/2006/relationships" id="266" r:id="R6289569d32d747ca"/>
-    <p:sldId xmlns:r="http://schemas.openxmlformats.org/officeDocument/2006/relationships" id="267" r:id="R2d8513a2d079453a"/>
-    <p:sldId xmlns:r="http://schemas.openxmlformats.org/officeDocument/2006/relationships" id="268" r:id="Ra0656b75767d49d6"/>
-    <p:sldId xmlns:r="http://schemas.openxmlformats.org/officeDocument/2006/relationships" id="269" r:id="R7b5789b1fce840f2"/>
-    <p:sldId xmlns:r="http://schemas.openxmlformats.org/officeDocument/2006/relationships" id="270" r:id="Rc991905cbfb343c1"/>
-    <p:sldId xmlns:r="http://schemas.openxmlformats.org/officeDocument/2006/relationships" id="271" r:id="R6b7134cf0248425b"/>
-    <p:sldId xmlns:r="http://schemas.openxmlformats.org/officeDocument/2006/relationships" id="272" r:id="R0029b270c8b4425f"/>
-    <p:sldId xmlns:r="http://schemas.openxmlformats.org/officeDocument/2006/relationships" id="273" r:id="R03c8628bf21b495f"/>
+    <p:sldId xmlns:r="http://schemas.openxmlformats.org/officeDocument/2006/relationships" id="256" r:id="Rbd15f076a1104525"/>
+    <p:sldId xmlns:r="http://schemas.openxmlformats.org/officeDocument/2006/relationships" id="257" r:id="R6f5dbfbc6c8442db"/>
+    <p:sldId xmlns:r="http://schemas.openxmlformats.org/officeDocument/2006/relationships" id="258" r:id="Rf4a4ad9cb05b4ef0"/>
+    <p:sldId xmlns:r="http://schemas.openxmlformats.org/officeDocument/2006/relationships" id="259" r:id="Ra6bcaffa0a2344f9"/>
+    <p:sldId xmlns:r="http://schemas.openxmlformats.org/officeDocument/2006/relationships" id="260" r:id="R958e39cf426446c5"/>
+    <p:sldId xmlns:r="http://schemas.openxmlformats.org/officeDocument/2006/relationships" id="261" r:id="Rd7fdc965e54b4b7e"/>
+    <p:sldId xmlns:r="http://schemas.openxmlformats.org/officeDocument/2006/relationships" id="262" r:id="R01e889c2c34949af"/>
+    <p:sldId xmlns:r="http://schemas.openxmlformats.org/officeDocument/2006/relationships" id="263" r:id="Rbfcafe4361ce481e"/>
+    <p:sldId xmlns:r="http://schemas.openxmlformats.org/officeDocument/2006/relationships" id="264" r:id="Rdf23c9da34704c2e"/>
+    <p:sldId xmlns:r="http://schemas.openxmlformats.org/officeDocument/2006/relationships" id="265" r:id="R7d974410be0c4b96"/>
+    <p:sldId xmlns:r="http://schemas.openxmlformats.org/officeDocument/2006/relationships" id="266" r:id="Reae354e62f894633"/>
+    <p:sldId xmlns:r="http://schemas.openxmlformats.org/officeDocument/2006/relationships" id="267" r:id="Rf5882ace95a242ea"/>
+    <p:sldId xmlns:r="http://schemas.openxmlformats.org/officeDocument/2006/relationships" id="268" r:id="Ra551e92a1a7a4076"/>
+    <p:sldId xmlns:r="http://schemas.openxmlformats.org/officeDocument/2006/relationships" id="269" r:id="R122501a48d794ea8"/>
+    <p:sldId xmlns:r="http://schemas.openxmlformats.org/officeDocument/2006/relationships" id="270" r:id="Rbd7876eded86474e"/>
+    <p:sldId xmlns:r="http://schemas.openxmlformats.org/officeDocument/2006/relationships" id="271" r:id="R43c765a8031b4f6c"/>
+    <p:sldId xmlns:r="http://schemas.openxmlformats.org/officeDocument/2006/relationships" id="272" r:id="R46b118f64da44105"/>
+    <p:sldId xmlns:r="http://schemas.openxmlformats.org/officeDocument/2006/relationships" id="273" r:id="R422fcd027f0f4bd5"/>
   </p:sldIdLst>
   <p:sldSz cx="12192000" cy="6858000"/>
   <p:notesSz cx="6858000" cy="9144000"/>
@@ -584,72 +584,32 @@
           <a:lstStyle xmlns:a="http://schemas.openxmlformats.org/drawingml/2006/main"/>
           <a:p xmlns:a="http://schemas.openxmlformats.org/drawingml/2006/main">
             <a:r>
-              <a:t>THURSDAY, Sep. 21–25 2026. APPLICATION · after the functions reading. SOURCE: Chapter 1 pp. 13–15 · SBTE 12–13. Printed textbook pages, not PDF viewer count. Total opener 3:00; 20s look, 40s choose, 50s check, 50s bridge, 20s buffer. Timer is teacher-controlled; on-slide times are static cues. If the section has not read the functions, use the plain-language choices A change the repair service, B ask preferences, C fix pickup. Reveal channel management as a preview and finish the reading before independent application.</a:t>
-            </a:r>
-          </a:p>
-          <a:p xmlns:a="http://schemas.openxmlformats.org/drawingml/2006/main">
-            <a:r>
-              <a:t>EXPECTED: C for the immediate distribution problem. MIM can reveal preferred pickup times and other functions support the repair; accept this distinction rather than claiming mutually exclusive categories.</a:t>
-            </a:r>
-          </a:p>
-          <a:p xmlns:a="http://schemas.openxmlformats.org/drawingml/2006/main">
-            <a:r>
-              <a:t>FOLLOW-UP 1 (optional, choose at most one): How could research help choose a better pickup time?</a:t>
-            </a:r>
-          </a:p>
-          <a:p xmlns:a="http://schemas.openxmlformats.org/drawingml/2006/main">
-            <a:r>
-              <a:t>FOLLOW-UP 2: Why wouldn’t a louder advertisement fix this alone?</a:t>
-            </a:r>
-          </a:p>
-          <a:p xmlns:a="http://schemas.openxmlformats.org/drawingml/2006/main">
-            <a:r>
-              <a:t>HARD STOP: “We’ve identified who organizes the handoff. Save the other fixes for our application.”</a:t>
-            </a:r>
-          </a:p>
-          <a:p xmlns:a="http://schemas.openxmlformats.org/drawingml/2006/main">
-            <a:r>
-              <a:t>TRANSITION: “Page 13 explains the distribution decisions; Figure 1.4 shows how they support customer needs.”</a:t>
-            </a:r>
-          </a:p>
-          <a:p xmlns:a="http://schemas.openxmlformats.org/drawingml/2006/main">
-            <a:r>
-              <a:t>SBTE: Take attendance during look/choose, scan participation discreetly, add one correction only if needed. Handoff: “Can you connect this to our notes?”</a:t>
-            </a:r>
-          </a:p>
-          <a:p xmlns:a="http://schemas.openxmlformats.org/drawingml/2006/main">
-            <a:r>
-              <a:t>MATCHED CHECK: How do channel management and place connect?</a:t>
-            </a:r>
-          </a:p>
-          <a:p xmlns:a="http://schemas.openxmlformats.org/drawingml/2006/main">
-            <a:r>
-              <a:t>KEY: Channel management coordinates distribution; place is that path within the marketing mix.</a:t>
-            </a:r>
-          </a:p>
-          <a:p xmlns:a="http://schemas.openxmlformats.org/drawingml/2006/main">
-            <a:r>
-              <a:t>PITER: Read the scenario once. Describe the three pictures. Give 20 seconds of quiet looking, then ask everyone for a response. Accept a private written choice. No partner transition.</a:t>
-            </a:r>
-          </a:p>
-          <a:p xmlns:a="http://schemas.openxmlformats.org/drawingml/2006/main">
-            <a:r>
-              <a:t>ACCESS: Read the short directions and describe the relevant visual aloud. Offer pointing, fingers, a written letter, or a quiet spoken response. Do not require eye contact, public disclosure, a phone, or speed. Keep printed response options available. No flashing, animation, or audible countdown.</a:t>
-            </a:r>
-          </a:p>
-          <a:p xmlns:a="http://schemas.openxmlformats.org/drawingml/2006/main">
-            <a:r>
-              <a:t>VISUAL SOURCE: Fictional generated illustrations; not actual students, school events, products, or prices. Repeated images intentionally preserve the scenario between prediction and academic explanation.</a:t>
-            </a:r>
-          </a:p>
-          <a:p xmlns:a="http://schemas.openxmlformats.org/drawingml/2006/main">
-            <a:r>
-              <a:t>SCENARIO: A repaired bicycle needs an after-school pickup or return arrangement. C, channel management, coordinates the service handoff. A improves repair quality. B researches preferences and can inform C. Link back explicitly: Tuesday named Place, a mix decision; today names the function that organizes access. Do not treat the functions as mutually exclusive.</a:t>
-            </a:r>
-          </a:p>
-          <a:p xmlns:a="http://schemas.openxmlformats.org/drawingml/2006/main">
-            <a:r>
-              <a:t>MATCHED CHECK EXAMPLE: A convenient pickup time shows channel management putting a Place decision into practice.</a:t>
+              <a:t>THURSDAY — 3 MINUTES MAX. Chapter 1 pp. 13–15, Channel Management and Figure 1.4; SBTE 12–13.</a:t>
+            </a:r>
+          </a:p>
+          <a:p xmlns:a="http://schemas.openxmlformats.org/drawingml/2006/main">
+            <a:r>
+              <a:t>SAY: A student’s bike is ready. But the shop closes before school ends, so the student cannot pick it up. What should the shop change? Read A, B, C once. Accept point, letter, fingers for position, or a quiet answer. Wait 10 seconds.</a:t>
+            </a:r>
+          </a:p>
+          <a:p xmlns:a="http://schemas.openxmlformats.org/drawingml/2006/main">
+            <a:r>
+              <a:t>CHECK: C, offer after-school pickup. The repair is already done. Asking about colors does not solve the pickup problem. Planning how, when, and where the customer receives the product connects to CHANNEL MANAGEMENT. Keep pointing to the same C image on both slides.</a:t>
+            </a:r>
+          </a:p>
+          <a:p xmlns:a="http://schemas.openxmlformats.org/drawingml/2006/main">
+            <a:r>
+              <a:t>OPTIONAL: Does repairing it again fix pickup? OR What changed: the repair, or how the customer receives it? Choose one only, 15 seconds.</a:t>
+            </a:r>
+          </a:p>
+          <a:p xmlns:a="http://schemas.openxmlformats.org/drawingml/2006/main">
+            <a:r>
+              <a:t>STOP: A finished repair still needs a workable pickup.</a:t>
+            </a:r>
+          </a:p>
+          <a:p xmlns:a="http://schemas.openxmlformats.org/drawingml/2006/main">
+            <a:r>
+              <a:t>TRANSITION: Open Channel Management on page 13. Find how products reach customers, then connect it to Figure 1.4 on page 15. SBTE resumes the source notes. 20s look, 40s choose, 50s check, 50s bridge, 20s buffer. Keep the academic term after the concrete choice, not as a prerequisite.</a:t>
             </a:r>
           </a:p>
         </p:txBody>
@@ -719,72 +679,32 @@
           <a:lstStyle xmlns:a="http://schemas.openxmlformats.org/drawingml/2006/main"/>
           <a:p xmlns:a="http://schemas.openxmlformats.org/drawingml/2006/main">
             <a:r>
-              <a:t>THURSDAY, Sep. 21–25 2026. APPLICATION · after the functions reading. SOURCE: Chapter 1 pp. 13–15 · SBTE 12–13. Printed textbook pages, not PDF viewer count. Total opener 3:00; 20s look, 40s choose, 50s check, 50s bridge, 20s buffer. Timer is teacher-controlled; on-slide times are static cues. If the section has not read the functions, use the plain-language choices A change the repair service, B ask preferences, C fix pickup. Reveal channel management as a preview and finish the reading before independent application.</a:t>
-            </a:r>
-          </a:p>
-          <a:p xmlns:a="http://schemas.openxmlformats.org/drawingml/2006/main">
-            <a:r>
-              <a:t>EXPECTED: C for the immediate distribution problem. MIM can reveal preferred pickup times and other functions support the repair; accept this distinction rather than claiming mutually exclusive categories.</a:t>
-            </a:r>
-          </a:p>
-          <a:p xmlns:a="http://schemas.openxmlformats.org/drawingml/2006/main">
-            <a:r>
-              <a:t>FOLLOW-UP 1 (optional, choose at most one): How could research help choose a better pickup time?</a:t>
-            </a:r>
-          </a:p>
-          <a:p xmlns:a="http://schemas.openxmlformats.org/drawingml/2006/main">
-            <a:r>
-              <a:t>FOLLOW-UP 2: Why wouldn’t a louder advertisement fix this alone?</a:t>
-            </a:r>
-          </a:p>
-          <a:p xmlns:a="http://schemas.openxmlformats.org/drawingml/2006/main">
-            <a:r>
-              <a:t>HARD STOP: “We’ve identified who organizes the handoff. Save the other fixes for our application.”</a:t>
-            </a:r>
-          </a:p>
-          <a:p xmlns:a="http://schemas.openxmlformats.org/drawingml/2006/main">
-            <a:r>
-              <a:t>TRANSITION: “Page 13 explains the distribution decisions; Figure 1.4 shows how they support customer needs.”</a:t>
-            </a:r>
-          </a:p>
-          <a:p xmlns:a="http://schemas.openxmlformats.org/drawingml/2006/main">
-            <a:r>
-              <a:t>SBTE: Take attendance during look/choose, scan participation discreetly, add one correction only if needed. Handoff: “Can you connect this to our notes?”</a:t>
-            </a:r>
-          </a:p>
-          <a:p xmlns:a="http://schemas.openxmlformats.org/drawingml/2006/main">
-            <a:r>
-              <a:t>MATCHED CHECK: How do channel management and place connect?</a:t>
-            </a:r>
-          </a:p>
-          <a:p xmlns:a="http://schemas.openxmlformats.org/drawingml/2006/main">
-            <a:r>
-              <a:t>KEY: Channel management coordinates distribution; place is that path within the marketing mix.</a:t>
-            </a:r>
-          </a:p>
-          <a:p xmlns:a="http://schemas.openxmlformats.org/drawingml/2006/main">
-            <a:r>
-              <a:t>PITER: Reveal and explain one visual clue. Use only one follow-up if time remains. Pointing alone shows selection; check explanation in the later matched lesson check.</a:t>
-            </a:r>
-          </a:p>
-          <a:p xmlns:a="http://schemas.openxmlformats.org/drawingml/2006/main">
-            <a:r>
-              <a:t>ACCESS: Read the short directions and describe the relevant visual aloud. Offer pointing, fingers, a written letter, or a quiet spoken response. Do not require eye contact, public disclosure, a phone, or speed. Keep printed response options available. No flashing, animation, or audible countdown.</a:t>
-            </a:r>
-          </a:p>
-          <a:p xmlns:a="http://schemas.openxmlformats.org/drawingml/2006/main">
-            <a:r>
-              <a:t>VISUAL SOURCE: Fictional generated illustrations; not actual students, school events, products, or prices. Repeated images intentionally preserve the scenario between prediction and academic explanation.</a:t>
-            </a:r>
-          </a:p>
-          <a:p xmlns:a="http://schemas.openxmlformats.org/drawingml/2006/main">
-            <a:r>
-              <a:t>SCENARIO: A repaired bicycle needs an after-school pickup or return arrangement. C, channel management, coordinates the service handoff. A improves repair quality. B researches preferences and can inform C. Link back explicitly: Tuesday named Place, a mix decision; today names the function that organizes access. Do not treat the functions as mutually exclusive.</a:t>
-            </a:r>
-          </a:p>
-          <a:p xmlns:a="http://schemas.openxmlformats.org/drawingml/2006/main">
-            <a:r>
-              <a:t>MATCHED CHECK EXAMPLE: A convenient pickup time shows channel management putting a Place decision into practice.</a:t>
+              <a:t>THURSDAY — 3 MINUTES MAX. Chapter 1 pp. 13–15, Channel Management and Figure 1.4; SBTE 12–13.</a:t>
+            </a:r>
+          </a:p>
+          <a:p xmlns:a="http://schemas.openxmlformats.org/drawingml/2006/main">
+            <a:r>
+              <a:t>SAY: A student’s bike is ready. But the shop closes before school ends, so the student cannot pick it up. What should the shop change? Read A, B, C once. Accept point, letter, fingers for position, or a quiet answer. Wait 10 seconds.</a:t>
+            </a:r>
+          </a:p>
+          <a:p xmlns:a="http://schemas.openxmlformats.org/drawingml/2006/main">
+            <a:r>
+              <a:t>CHECK: C, offer after-school pickup. The repair is already done. Asking about colors does not solve the pickup problem. Planning how, when, and where the customer receives the product connects to CHANNEL MANAGEMENT. Keep pointing to the same C image on both slides.</a:t>
+            </a:r>
+          </a:p>
+          <a:p xmlns:a="http://schemas.openxmlformats.org/drawingml/2006/main">
+            <a:r>
+              <a:t>OPTIONAL: Does repairing it again fix pickup? OR What changed: the repair, or how the customer receives it? Choose one only, 15 seconds.</a:t>
+            </a:r>
+          </a:p>
+          <a:p xmlns:a="http://schemas.openxmlformats.org/drawingml/2006/main">
+            <a:r>
+              <a:t>STOP: A finished repair still needs a workable pickup.</a:t>
+            </a:r>
+          </a:p>
+          <a:p xmlns:a="http://schemas.openxmlformats.org/drawingml/2006/main">
+            <a:r>
+              <a:t>TRANSITION: Open Channel Management on page 13. Find how products reach customers, then connect it to Figure 1.4 on page 15. SBTE resumes the source notes. 20s look, 40s choose, 50s check, 50s bridge, 20s buffer. Keep the academic term after the concrete choice, not as a prerequisite.</a:t>
             </a:r>
           </a:p>
         </p:txBody>
@@ -854,72 +774,32 @@
           <a:lstStyle xmlns:a="http://schemas.openxmlformats.org/drawingml/2006/main"/>
           <a:p xmlns:a="http://schemas.openxmlformats.org/drawingml/2006/main">
             <a:r>
-              <a:t>THURSDAY, Sep. 21–25 2026. APPLICATION · after the functions reading. SOURCE: Chapter 1 pp. 13–15 · SBTE 12–13. Printed textbook pages, not PDF viewer count. Total opener 3:00; 20s look, 40s choose, 50s check, 50s bridge, 20s buffer. Timer is teacher-controlled; on-slide times are static cues. If the section has not read the functions, use the plain-language choices A change the repair service, B ask preferences, C fix pickup. Reveal channel management as a preview and finish the reading before independent application.</a:t>
-            </a:r>
-          </a:p>
-          <a:p xmlns:a="http://schemas.openxmlformats.org/drawingml/2006/main">
-            <a:r>
-              <a:t>EXPECTED: C for the immediate distribution problem. MIM can reveal preferred pickup times and other functions support the repair; accept this distinction rather than claiming mutually exclusive categories.</a:t>
-            </a:r>
-          </a:p>
-          <a:p xmlns:a="http://schemas.openxmlformats.org/drawingml/2006/main">
-            <a:r>
-              <a:t>FOLLOW-UP 1 (optional, choose at most one): How could research help choose a better pickup time?</a:t>
-            </a:r>
-          </a:p>
-          <a:p xmlns:a="http://schemas.openxmlformats.org/drawingml/2006/main">
-            <a:r>
-              <a:t>FOLLOW-UP 2: Why wouldn’t a louder advertisement fix this alone?</a:t>
-            </a:r>
-          </a:p>
-          <a:p xmlns:a="http://schemas.openxmlformats.org/drawingml/2006/main">
-            <a:r>
-              <a:t>HARD STOP: “We’ve identified who organizes the handoff. Save the other fixes for our application.”</a:t>
-            </a:r>
-          </a:p>
-          <a:p xmlns:a="http://schemas.openxmlformats.org/drawingml/2006/main">
-            <a:r>
-              <a:t>TRANSITION: “Page 13 explains the distribution decisions; Figure 1.4 shows how they support customer needs.”</a:t>
-            </a:r>
-          </a:p>
-          <a:p xmlns:a="http://schemas.openxmlformats.org/drawingml/2006/main">
-            <a:r>
-              <a:t>SBTE: Take attendance during look/choose, scan participation discreetly, add one correction only if needed. Handoff: “Can you connect this to our notes?”</a:t>
-            </a:r>
-          </a:p>
-          <a:p xmlns:a="http://schemas.openxmlformats.org/drawingml/2006/main">
-            <a:r>
-              <a:t>MATCHED CHECK: How do channel management and place connect?</a:t>
-            </a:r>
-          </a:p>
-          <a:p xmlns:a="http://schemas.openxmlformats.org/drawingml/2006/main">
-            <a:r>
-              <a:t>KEY: Channel management coordinates distribution; place is that path within the marketing mix.</a:t>
-            </a:r>
-          </a:p>
-          <a:p xmlns:a="http://schemas.openxmlformats.org/drawingml/2006/main">
-            <a:r>
-              <a:t>PITER: Say the one-line closer. Students locate the named heading, not an unfamiliar page number alone. End the opener, then use the appropriate notes/readings.</a:t>
-            </a:r>
-          </a:p>
-          <a:p xmlns:a="http://schemas.openxmlformats.org/drawingml/2006/main">
-            <a:r>
-              <a:t>ACCESS: Read the short directions and describe the relevant visual aloud. Offer pointing, fingers, a written letter, or a quiet spoken response. Do not require eye contact, public disclosure, a phone, or speed. Keep printed response options available. No flashing, animation, or audible countdown.</a:t>
-            </a:r>
-          </a:p>
-          <a:p xmlns:a="http://schemas.openxmlformats.org/drawingml/2006/main">
-            <a:r>
-              <a:t>VISUAL SOURCE: Fictional generated illustrations; not actual students, school events, products, or prices. Repeated images intentionally preserve the scenario between prediction and academic explanation.</a:t>
-            </a:r>
-          </a:p>
-          <a:p xmlns:a="http://schemas.openxmlformats.org/drawingml/2006/main">
-            <a:r>
-              <a:t>SCENARIO: A repaired bicycle needs an after-school pickup or return arrangement. C, channel management, coordinates the service handoff. A improves repair quality. B researches preferences and can inform C. Link back explicitly: Tuesday named Place, a mix decision; today names the function that organizes access. Do not treat the functions as mutually exclusive.</a:t>
-            </a:r>
-          </a:p>
-          <a:p xmlns:a="http://schemas.openxmlformats.org/drawingml/2006/main">
-            <a:r>
-              <a:t>MATCHED CHECK EXAMPLE: A convenient pickup time shows channel management putting a Place decision into practice.</a:t>
+              <a:t>THURSDAY — 3 MINUTES MAX. Chapter 1 pp. 13–15, Channel Management and Figure 1.4; SBTE 12–13.</a:t>
+            </a:r>
+          </a:p>
+          <a:p xmlns:a="http://schemas.openxmlformats.org/drawingml/2006/main">
+            <a:r>
+              <a:t>SAY: A student’s bike is ready. But the shop closes before school ends, so the student cannot pick it up. What should the shop change? Read A, B, C once. Accept point, letter, fingers for position, or a quiet answer. Wait 10 seconds.</a:t>
+            </a:r>
+          </a:p>
+          <a:p xmlns:a="http://schemas.openxmlformats.org/drawingml/2006/main">
+            <a:r>
+              <a:t>CHECK: C, offer after-school pickup. The repair is already done. Asking about colors does not solve the pickup problem. Planning how, when, and where the customer receives the product connects to CHANNEL MANAGEMENT. Keep pointing to the same C image on both slides.</a:t>
+            </a:r>
+          </a:p>
+          <a:p xmlns:a="http://schemas.openxmlformats.org/drawingml/2006/main">
+            <a:r>
+              <a:t>OPTIONAL: Does repairing it again fix pickup? OR What changed: the repair, or how the customer receives it? Choose one only, 15 seconds.</a:t>
+            </a:r>
+          </a:p>
+          <a:p xmlns:a="http://schemas.openxmlformats.org/drawingml/2006/main">
+            <a:r>
+              <a:t>STOP: A finished repair still needs a workable pickup.</a:t>
+            </a:r>
+          </a:p>
+          <a:p xmlns:a="http://schemas.openxmlformats.org/drawingml/2006/main">
+            <a:r>
+              <a:t>TRANSITION: Open Channel Management on page 13. Find how products reach customers, then connect it to Figure 1.4 on page 15. SBTE resumes the source notes. 20s look, 40s choose, 50s check, 50s bridge, 20s buffer. Keep the academic term after the concrete choice, not as a prerequisite.</a:t>
             </a:r>
           </a:p>
         </p:txBody>
@@ -1809,67 +1689,32 @@
           <a:lstStyle xmlns:a="http://schemas.openxmlformats.org/drawingml/2006/main"/>
           <a:p xmlns:a="http://schemas.openxmlformats.org/drawingml/2006/main">
             <a:r>
-              <a:t>TUESDAY, Sep. 21–25 2026. PREVIEW · no prior 4 Ps knowledge needed. SOURCE: Chapter 1 pp. 11–12 · SBTE 10. Printed textbook pages, not PDF viewer count. Total opener 3:00; 20s look, 40s choose, 50s check, 50s bridge, 20s buffer. Timer is teacher-controlled; on-slide times are static cues. Preview through an everyday problem, then reveal the term. Do not quiz students on untaught P labels. Fictional delivery; no real school shipping promise. Terms to Know deadline is 9 AM today, not necessarily before this section meets.</a:t>
-            </a:r>
-          </a:p>
-          <a:p xmlns:a="http://schemas.openxmlformats.org/drawingml/2006/main">
-            <a:r>
-              <a:t>EXPECTED: C. The missed event is a delivery/distribution problem. A better ad or new package would not fix the stated problem.</a:t>
-            </a:r>
-          </a:p>
-          <a:p xmlns:a="http://schemas.openxmlformats.org/drawingml/2006/main">
-            <a:r>
-              <a:t>FOLLOW-UP 1 (optional, choose at most one): Could a great product still disappoint a customer? How?</a:t>
-            </a:r>
-          </a:p>
-          <a:p xmlns:a="http://schemas.openxmlformats.org/drawingml/2006/main">
-            <a:r>
-              <a:t>FOLLOW-UP 2: Which detail tells you delivery is the issue?</a:t>
-            </a:r>
-          </a:p>
-          <a:p xmlns:a="http://schemas.openxmlformats.org/drawingml/2006/main">
-            <a:r>
-              <a:t>HARD STOP: “Lock in your choice. Let’s name the concept and go to the reading.”</a:t>
-            </a:r>
-          </a:p>
-          <a:p xmlns:a="http://schemas.openxmlformats.org/drawingml/2006/main">
-            <a:r>
-              <a:t>TRANSITION: “Keep that late popcorn order in mind. Pages 11–12 explain all four decisions in the marketing mix.”</a:t>
-            </a:r>
-          </a:p>
-          <a:p xmlns:a="http://schemas.openxmlformats.org/drawingml/2006/main">
-            <a:r>
-              <a:t>SBTE: Take attendance during look/choose, scan participation discreetly, add one correction only if needed. Handoff: “Can you connect this to our notes?”</a:t>
-            </a:r>
-          </a:p>
-          <a:p xmlns:a="http://schemas.openxmlformats.org/drawingml/2006/main">
-            <a:r>
-              <a:t>MATCHED CHECK: A popcorn order is advertised well but arrives too late. Which P needs attention, and why?</a:t>
-            </a:r>
-          </a:p>
-          <a:p xmlns:a="http://schemas.openxmlformats.org/drawingml/2006/main">
-            <a:r>
-              <a:t>KEY: Place; distribution did not deliver it when needed.</a:t>
-            </a:r>
-          </a:p>
-          <a:p xmlns:a="http://schemas.openxmlformats.org/drawingml/2006/main">
-            <a:r>
-              <a:t>PITER: Read the scenario once. Describe the three pictures. Give 20 seconds of quiet looking, then ask everyone for a response. Accept a private written choice. No partner transition.</a:t>
-            </a:r>
-          </a:p>
-          <a:p xmlns:a="http://schemas.openxmlformats.org/drawingml/2006/main">
-            <a:r>
-              <a:t>ACCESS: Read the short directions and describe the relevant visual aloud. Offer pointing, fingers, a written letter, or a quiet spoken response. Do not require eye contact, public disclosure, a phone, or speed. Keep printed response options available. No flashing, animation, or audible countdown.</a:t>
-            </a:r>
-          </a:p>
-          <a:p xmlns:a="http://schemas.openxmlformats.org/drawingml/2006/main">
-            <a:r>
-              <a:t>VISUAL SOURCE: Fictional generated illustrations; not actual students, school events, products, or prices. Repeated images intentionally preserve the scenario between prediction and academic explanation.</a:t>
-            </a:r>
-          </a:p>
-          <a:p xmlns:a="http://schemas.openxmlformats.org/drawingml/2006/main">
-            <a:r>
-              <a:t>SCENARIO: Packaged popcorn arrives after a fictional school event. Options: change packaging, make a bigger ad, or deliver before the event. C addresses Place. This is not Monday’s merchandise choice. Explain that no actual food sale is planned.</a:t>
+              <a:t>TUESDAY — 3 MINUTES MAX. Chapter 1 pp. 11–12, Marketing Mix; SBTE 10.</a:t>
+            </a:r>
+          </a:p>
+          <a:p xmlns:a="http://schemas.openxmlformats.org/drawingml/2006/main">
+            <a:r>
+              <a:t>SAY: The school club ordered popcorn ahead of time, but the seller delivered it after the game. For the next game, should the seller change the packaging, make a bigger ad, or deliver before the game? Point, say C, or write C. Wait 10 seconds after reading choices.</a:t>
+            </a:r>
+          </a:p>
+          <a:p xmlns:a="http://schemas.openxmlformats.org/drawingml/2006/main">
+            <a:r>
+              <a:t>CHECK: C. The problem is getting the product to customers when they need it. In the marketing mix, that is PLACE. New packaging and a bigger ad do not fix a late delivery. The delivery picture illustrates the late arrival, not a successful on-time delivery.</a:t>
+            </a:r>
+          </a:p>
+          <a:p xmlns:a="http://schemas.openxmlformats.org/drawingml/2006/main">
+            <a:r>
+              <a:t>OPTIONAL: Would new packaging fix the timing? OR Why does the delivery time matter? Choose one only, 15 seconds.</a:t>
+            </a:r>
+          </a:p>
+          <a:p xmlns:a="http://schemas.openxmlformats.org/drawingml/2006/main">
+            <a:r>
+              <a:t>STOP: A product has to reach its customer at the right time.</a:t>
+            </a:r>
+          </a:p>
+          <a:p xmlns:a="http://schemas.openxmlformats.org/drawingml/2006/main">
+            <a:r>
+              <a:t>TRANSITION: Open Marketing Mix on pages 11–12. Find place, alongside product, promotion, and price. SBTE resumes notes. 20s look, 40s choose, 50s check, 50s bridge, 20s buffer. Fictional example; no personal purchase required.</a:t>
             </a:r>
           </a:p>
         </p:txBody>
@@ -1939,67 +1784,32 @@
           <a:lstStyle xmlns:a="http://schemas.openxmlformats.org/drawingml/2006/main"/>
           <a:p xmlns:a="http://schemas.openxmlformats.org/drawingml/2006/main">
             <a:r>
-              <a:t>TUESDAY, Sep. 21–25 2026. PREVIEW · no prior 4 Ps knowledge needed. SOURCE: Chapter 1 pp. 11–12 · SBTE 10. Printed textbook pages, not PDF viewer count. Total opener 3:00; 20s look, 40s choose, 50s check, 50s bridge, 20s buffer. Timer is teacher-controlled; on-slide times are static cues. Preview through an everyday problem, then reveal the term. Do not quiz students on untaught P labels. Fictional delivery; no real school shipping promise. Terms to Know deadline is 9 AM today, not necessarily before this section meets.</a:t>
-            </a:r>
-          </a:p>
-          <a:p xmlns:a="http://schemas.openxmlformats.org/drawingml/2006/main">
-            <a:r>
-              <a:t>EXPECTED: C. The missed event is a delivery/distribution problem. A better ad or new package would not fix the stated problem.</a:t>
-            </a:r>
-          </a:p>
-          <a:p xmlns:a="http://schemas.openxmlformats.org/drawingml/2006/main">
-            <a:r>
-              <a:t>FOLLOW-UP 1 (optional, choose at most one): Could a great product still disappoint a customer? How?</a:t>
-            </a:r>
-          </a:p>
-          <a:p xmlns:a="http://schemas.openxmlformats.org/drawingml/2006/main">
-            <a:r>
-              <a:t>FOLLOW-UP 2: Which detail tells you delivery is the issue?</a:t>
-            </a:r>
-          </a:p>
-          <a:p xmlns:a="http://schemas.openxmlformats.org/drawingml/2006/main">
-            <a:r>
-              <a:t>HARD STOP: “Lock in your choice. Let’s name the concept and go to the reading.”</a:t>
-            </a:r>
-          </a:p>
-          <a:p xmlns:a="http://schemas.openxmlformats.org/drawingml/2006/main">
-            <a:r>
-              <a:t>TRANSITION: “Keep that late popcorn order in mind. Pages 11–12 explain all four decisions in the marketing mix.”</a:t>
-            </a:r>
-          </a:p>
-          <a:p xmlns:a="http://schemas.openxmlformats.org/drawingml/2006/main">
-            <a:r>
-              <a:t>SBTE: Take attendance during look/choose, scan participation discreetly, add one correction only if needed. Handoff: “Can you connect this to our notes?”</a:t>
-            </a:r>
-          </a:p>
-          <a:p xmlns:a="http://schemas.openxmlformats.org/drawingml/2006/main">
-            <a:r>
-              <a:t>MATCHED CHECK: A popcorn order is advertised well but arrives too late. Which P needs attention, and why?</a:t>
-            </a:r>
-          </a:p>
-          <a:p xmlns:a="http://schemas.openxmlformats.org/drawingml/2006/main">
-            <a:r>
-              <a:t>KEY: Place; distribution did not deliver it when needed.</a:t>
-            </a:r>
-          </a:p>
-          <a:p xmlns:a="http://schemas.openxmlformats.org/drawingml/2006/main">
-            <a:r>
-              <a:t>PITER: Reveal and explain one visual clue. Use only one follow-up if time remains. Pointing alone shows selection; check explanation in the later matched lesson check.</a:t>
-            </a:r>
-          </a:p>
-          <a:p xmlns:a="http://schemas.openxmlformats.org/drawingml/2006/main">
-            <a:r>
-              <a:t>ACCESS: Read the short directions and describe the relevant visual aloud. Offer pointing, fingers, a written letter, or a quiet spoken response. Do not require eye contact, public disclosure, a phone, or speed. Keep printed response options available. No flashing, animation, or audible countdown.</a:t>
-            </a:r>
-          </a:p>
-          <a:p xmlns:a="http://schemas.openxmlformats.org/drawingml/2006/main">
-            <a:r>
-              <a:t>VISUAL SOURCE: Fictional generated illustrations; not actual students, school events, products, or prices. Repeated images intentionally preserve the scenario between prediction and academic explanation.</a:t>
-            </a:r>
-          </a:p>
-          <a:p xmlns:a="http://schemas.openxmlformats.org/drawingml/2006/main">
-            <a:r>
-              <a:t>SCENARIO: Packaged popcorn arrives after a fictional school event. Options: change packaging, make a bigger ad, or deliver before the event. C addresses Place. This is not Monday’s merchandise choice. Explain that no actual food sale is planned.</a:t>
+              <a:t>TUESDAY — 3 MINUTES MAX. Chapter 1 pp. 11–12, Marketing Mix; SBTE 10.</a:t>
+            </a:r>
+          </a:p>
+          <a:p xmlns:a="http://schemas.openxmlformats.org/drawingml/2006/main">
+            <a:r>
+              <a:t>SAY: The school club ordered popcorn ahead of time, but the seller delivered it after the game. For the next game, should the seller change the packaging, make a bigger ad, or deliver before the game? Point, say C, or write C. Wait 10 seconds after reading choices.</a:t>
+            </a:r>
+          </a:p>
+          <a:p xmlns:a="http://schemas.openxmlformats.org/drawingml/2006/main">
+            <a:r>
+              <a:t>CHECK: C. The problem is getting the product to customers when they need it. In the marketing mix, that is PLACE. New packaging and a bigger ad do not fix a late delivery. The delivery picture illustrates the late arrival, not a successful on-time delivery.</a:t>
+            </a:r>
+          </a:p>
+          <a:p xmlns:a="http://schemas.openxmlformats.org/drawingml/2006/main">
+            <a:r>
+              <a:t>OPTIONAL: Would new packaging fix the timing? OR Why does the delivery time matter? Choose one only, 15 seconds.</a:t>
+            </a:r>
+          </a:p>
+          <a:p xmlns:a="http://schemas.openxmlformats.org/drawingml/2006/main">
+            <a:r>
+              <a:t>STOP: A product has to reach its customer at the right time.</a:t>
+            </a:r>
+          </a:p>
+          <a:p xmlns:a="http://schemas.openxmlformats.org/drawingml/2006/main">
+            <a:r>
+              <a:t>TRANSITION: Open Marketing Mix on pages 11–12. Find place, alongside product, promotion, and price. SBTE resumes notes. 20s look, 40s choose, 50s check, 50s bridge, 20s buffer. Fictional example; no personal purchase required.</a:t>
             </a:r>
           </a:p>
         </p:txBody>
@@ -2069,67 +1879,32 @@
           <a:lstStyle xmlns:a="http://schemas.openxmlformats.org/drawingml/2006/main"/>
           <a:p xmlns:a="http://schemas.openxmlformats.org/drawingml/2006/main">
             <a:r>
-              <a:t>TUESDAY, Sep. 21–25 2026. PREVIEW · no prior 4 Ps knowledge needed. SOURCE: Chapter 1 pp. 11–12 · SBTE 10. Printed textbook pages, not PDF viewer count. Total opener 3:00; 20s look, 40s choose, 50s check, 50s bridge, 20s buffer. Timer is teacher-controlled; on-slide times are static cues. Preview through an everyday problem, then reveal the term. Do not quiz students on untaught P labels. Fictional delivery; no real school shipping promise. Terms to Know deadline is 9 AM today, not necessarily before this section meets.</a:t>
-            </a:r>
-          </a:p>
-          <a:p xmlns:a="http://schemas.openxmlformats.org/drawingml/2006/main">
-            <a:r>
-              <a:t>EXPECTED: C. The missed event is a delivery/distribution problem. A better ad or new package would not fix the stated problem.</a:t>
-            </a:r>
-          </a:p>
-          <a:p xmlns:a="http://schemas.openxmlformats.org/drawingml/2006/main">
-            <a:r>
-              <a:t>FOLLOW-UP 1 (optional, choose at most one): Could a great product still disappoint a customer? How?</a:t>
-            </a:r>
-          </a:p>
-          <a:p xmlns:a="http://schemas.openxmlformats.org/drawingml/2006/main">
-            <a:r>
-              <a:t>FOLLOW-UP 2: Which detail tells you delivery is the issue?</a:t>
-            </a:r>
-          </a:p>
-          <a:p xmlns:a="http://schemas.openxmlformats.org/drawingml/2006/main">
-            <a:r>
-              <a:t>HARD STOP: “Lock in your choice. Let’s name the concept and go to the reading.”</a:t>
-            </a:r>
-          </a:p>
-          <a:p xmlns:a="http://schemas.openxmlformats.org/drawingml/2006/main">
-            <a:r>
-              <a:t>TRANSITION: “Keep that late popcorn order in mind. Pages 11–12 explain all four decisions in the marketing mix.”</a:t>
-            </a:r>
-          </a:p>
-          <a:p xmlns:a="http://schemas.openxmlformats.org/drawingml/2006/main">
-            <a:r>
-              <a:t>SBTE: Take attendance during look/choose, scan participation discreetly, add one correction only if needed. Handoff: “Can you connect this to our notes?”</a:t>
-            </a:r>
-          </a:p>
-          <a:p xmlns:a="http://schemas.openxmlformats.org/drawingml/2006/main">
-            <a:r>
-              <a:t>MATCHED CHECK: A popcorn order is advertised well but arrives too late. Which P needs attention, and why?</a:t>
-            </a:r>
-          </a:p>
-          <a:p xmlns:a="http://schemas.openxmlformats.org/drawingml/2006/main">
-            <a:r>
-              <a:t>KEY: Place; distribution did not deliver it when needed.</a:t>
-            </a:r>
-          </a:p>
-          <a:p xmlns:a="http://schemas.openxmlformats.org/drawingml/2006/main">
-            <a:r>
-              <a:t>PITER: Say the one-line closer. Students locate the named heading, not an unfamiliar page number alone. End the opener, then use the appropriate notes/readings.</a:t>
-            </a:r>
-          </a:p>
-          <a:p xmlns:a="http://schemas.openxmlformats.org/drawingml/2006/main">
-            <a:r>
-              <a:t>ACCESS: Read the short directions and describe the relevant visual aloud. Offer pointing, fingers, a written letter, or a quiet spoken response. Do not require eye contact, public disclosure, a phone, or speed. Keep printed response options available. No flashing, animation, or audible countdown.</a:t>
-            </a:r>
-          </a:p>
-          <a:p xmlns:a="http://schemas.openxmlformats.org/drawingml/2006/main">
-            <a:r>
-              <a:t>VISUAL SOURCE: Fictional generated illustrations; not actual students, school events, products, or prices. Repeated images intentionally preserve the scenario between prediction and academic explanation.</a:t>
-            </a:r>
-          </a:p>
-          <a:p xmlns:a="http://schemas.openxmlformats.org/drawingml/2006/main">
-            <a:r>
-              <a:t>SCENARIO: Packaged popcorn arrives after a fictional school event. Options: change packaging, make a bigger ad, or deliver before the event. C addresses Place. This is not Monday’s merchandise choice. Explain that no actual food sale is planned.</a:t>
+              <a:t>TUESDAY — 3 MINUTES MAX. Chapter 1 pp. 11–12, Marketing Mix; SBTE 10.</a:t>
+            </a:r>
+          </a:p>
+          <a:p xmlns:a="http://schemas.openxmlformats.org/drawingml/2006/main">
+            <a:r>
+              <a:t>SAY: The school club ordered popcorn ahead of time, but the seller delivered it after the game. For the next game, should the seller change the packaging, make a bigger ad, or deliver before the game? Point, say C, or write C. Wait 10 seconds after reading choices.</a:t>
+            </a:r>
+          </a:p>
+          <a:p xmlns:a="http://schemas.openxmlformats.org/drawingml/2006/main">
+            <a:r>
+              <a:t>CHECK: C. The problem is getting the product to customers when they need it. In the marketing mix, that is PLACE. New packaging and a bigger ad do not fix a late delivery. The delivery picture illustrates the late arrival, not a successful on-time delivery.</a:t>
+            </a:r>
+          </a:p>
+          <a:p xmlns:a="http://schemas.openxmlformats.org/drawingml/2006/main">
+            <a:r>
+              <a:t>OPTIONAL: Would new packaging fix the timing? OR Why does the delivery time matter? Choose one only, 15 seconds.</a:t>
+            </a:r>
+          </a:p>
+          <a:p xmlns:a="http://schemas.openxmlformats.org/drawingml/2006/main">
+            <a:r>
+              <a:t>STOP: A product has to reach its customer at the right time.</a:t>
+            </a:r>
+          </a:p>
+          <a:p xmlns:a="http://schemas.openxmlformats.org/drawingml/2006/main">
+            <a:r>
+              <a:t>TRANSITION: Open Marketing Mix on pages 11–12. Find place, alongside product, promotion, and price. SBTE resumes notes. 20s look, 40s choose, 50s check, 50s bridge, 20s buffer. Fictional example; no personal purchase required.</a:t>
             </a:r>
           </a:p>
         </p:txBody>
@@ -2582,7 +2357,7 @@
   </p:cSld>
   <p:clrMap bg1="lt1" tx1="dk1" bg2="lt2" tx2="dk2" accent1="accent1" accent2="accent2" accent3="accent3" accent4="accent4" accent5="accent5" accent6="accent6" hlink="hlink" folHlink="folHlink"/>
   <p:sldLayoutIdLst>
-    <p:sldLayoutId xmlns:r="http://schemas.openxmlformats.org/officeDocument/2006/relationships" id="2147483649" r:id="Ra9bbabbda55a41ca"/>
+    <p:sldLayoutId xmlns:r="http://schemas.openxmlformats.org/officeDocument/2006/relationships" id="2147483649" r:id="R7e964593632e423c"/>
   </p:sldLayoutIdLst>
   <p:txStyles>
     <p:titleStyle>
@@ -3457,7 +3232,7 @@
           <p:nvPr/>
         </p:nvPicPr>
         <p:blipFill>
-          <a:blip xmlns:r="http://schemas.openxmlformats.org/officeDocument/2006/relationships" xmlns:a="http://schemas.openxmlformats.org/drawingml/2006/main" r:embed="R6cf6b60706724637"/>
+          <a:blip xmlns:r="http://schemas.openxmlformats.org/officeDocument/2006/relationships" xmlns:a="http://schemas.openxmlformats.org/drawingml/2006/main" r:embed="R517ef34e43f64bf2"/>
           <a:stretch xmlns:a="http://schemas.openxmlformats.org/drawingml/2006/main"/>
         </p:blipFill>
         <p:spPr>
@@ -3537,7 +3312,7 @@
           <p:nvPr/>
         </p:nvPicPr>
         <p:blipFill>
-          <a:blip xmlns:r="http://schemas.openxmlformats.org/officeDocument/2006/relationships" xmlns:a="http://schemas.openxmlformats.org/drawingml/2006/main" r:embed="R048ed9a052734c42"/>
+          <a:blip xmlns:r="http://schemas.openxmlformats.org/officeDocument/2006/relationships" xmlns:a="http://schemas.openxmlformats.org/drawingml/2006/main" r:embed="R968b717066bf42f5"/>
           <a:stretch xmlns:a="http://schemas.openxmlformats.org/drawingml/2006/main"/>
         </p:blipFill>
         <p:spPr>
@@ -3617,7 +3392,7 @@
           <p:nvPr/>
         </p:nvPicPr>
         <p:blipFill>
-          <a:blip xmlns:r="http://schemas.openxmlformats.org/officeDocument/2006/relationships" xmlns:a="http://schemas.openxmlformats.org/drawingml/2006/main" r:embed="R9f9c319220674c9c"/>
+          <a:blip xmlns:r="http://schemas.openxmlformats.org/officeDocument/2006/relationships" xmlns:a="http://schemas.openxmlformats.org/drawingml/2006/main" r:embed="Rf8ec1bebfa6e431b"/>
           <a:stretch xmlns:a="http://schemas.openxmlformats.org/drawingml/2006/main"/>
         </p:blipFill>
         <p:spPr>
@@ -4062,7 +3837,7 @@
                 <a:ea typeface="Arial"/>
                 <a:cs typeface="Arial"/>
               </a:rPr>
-              <a:t>The bike is fixed. How will it get back?</a:t>
+              <a:t>Bike ready. Pickup closes too early.</a:t>
             </a:r>
           </a:p>
         </p:txBody>
@@ -4120,7 +3895,7 @@
                 <a:ea typeface="Arial"/>
                 <a:cs typeface="Arial"/>
               </a:rPr>
-              <a:t>A repair shop needs a pickup option students can use after school.</a:t>
+              <a:t>The shop closes before school ends. The student cannot collect it.</a:t>
             </a:r>
           </a:p>
         </p:txBody>
@@ -4178,7 +3953,7 @@
                 <a:ea typeface="Arial"/>
                 <a:cs typeface="Arial"/>
               </a:rPr>
-              <a:t>Which function organizes the handoff?</a:t>
+              <a:t>What should the shop change so pickup works?</a:t>
             </a:r>
           </a:p>
         </p:txBody>
@@ -4192,7 +3967,7 @@
           <p:nvPr/>
         </p:nvPicPr>
         <p:blipFill>
-          <a:blip xmlns:r="http://schemas.openxmlformats.org/officeDocument/2006/relationships" xmlns:a="http://schemas.openxmlformats.org/drawingml/2006/main" r:embed="R206d5ca7b9934910"/>
+          <a:blip xmlns:r="http://schemas.openxmlformats.org/officeDocument/2006/relationships" xmlns:a="http://schemas.openxmlformats.org/drawingml/2006/main" r:embed="R9594dbe718ad4035"/>
           <a:stretch xmlns:a="http://schemas.openxmlformats.org/drawingml/2006/main"/>
         </p:blipFill>
         <p:spPr>
@@ -4258,7 +4033,7 @@
                 <a:ea typeface="Arial"/>
                 <a:cs typeface="Arial"/>
               </a:rPr>
-              <a:t>A  Product/service management</a:t>
+              <a:t>A  Repair the bike again</a:t>
             </a:r>
           </a:p>
         </p:txBody>
@@ -4272,7 +4047,7 @@
           <p:nvPr/>
         </p:nvPicPr>
         <p:blipFill>
-          <a:blip xmlns:r="http://schemas.openxmlformats.org/officeDocument/2006/relationships" xmlns:a="http://schemas.openxmlformats.org/drawingml/2006/main" r:embed="Ra002ad2869134547"/>
+          <a:blip xmlns:r="http://schemas.openxmlformats.org/officeDocument/2006/relationships" xmlns:a="http://schemas.openxmlformats.org/drawingml/2006/main" r:embed="Rf882408cf275404b"/>
           <a:stretch xmlns:a="http://schemas.openxmlformats.org/drawingml/2006/main"/>
         </p:blipFill>
         <p:spPr>
@@ -4338,7 +4113,7 @@
                 <a:ea typeface="Arial"/>
                 <a:cs typeface="Arial"/>
               </a:rPr>
-              <a:t>B  Marketing information management</a:t>
+              <a:t>B  Ask about favorite bike colors</a:t>
             </a:r>
           </a:p>
         </p:txBody>
@@ -4352,7 +4127,7 @@
           <p:nvPr/>
         </p:nvPicPr>
         <p:blipFill>
-          <a:blip xmlns:r="http://schemas.openxmlformats.org/officeDocument/2006/relationships" xmlns:a="http://schemas.openxmlformats.org/drawingml/2006/main" r:embed="R987b3b310ff541ef"/>
+          <a:blip xmlns:r="http://schemas.openxmlformats.org/officeDocument/2006/relationships" xmlns:a="http://schemas.openxmlformats.org/drawingml/2006/main" r:embed="Rbf0c4c9583254623"/>
           <a:stretch xmlns:a="http://schemas.openxmlformats.org/drawingml/2006/main"/>
         </p:blipFill>
         <p:spPr>
@@ -4418,7 +4193,7 @@
                 <a:ea typeface="Arial"/>
                 <a:cs typeface="Arial"/>
               </a:rPr>
-              <a:t>C  Channel management</a:t>
+              <a:t>C  Offer after-school pickup</a:t>
             </a:r>
           </a:p>
         </p:txBody>
@@ -4797,7 +4572,7 @@
                 <a:ea typeface="Arial"/>
                 <a:cs typeface="Arial"/>
               </a:rPr>
-              <a:t>C  Channel management</a:t>
+              <a:t>C  Offer after-school pickup</a:t>
             </a:r>
           </a:p>
         </p:txBody>
@@ -4869,7 +4644,7 @@
           <p:nvPr/>
         </p:nvPicPr>
         <p:blipFill>
-          <a:blip xmlns:r="http://schemas.openxmlformats.org/officeDocument/2006/relationships" xmlns:a="http://schemas.openxmlformats.org/drawingml/2006/main" r:embed="R9901eaf75c8e4962"/>
+          <a:blip xmlns:r="http://schemas.openxmlformats.org/officeDocument/2006/relationships" xmlns:a="http://schemas.openxmlformats.org/drawingml/2006/main" r:embed="R98c25c3e37a649bf"/>
           <a:stretch xmlns:a="http://schemas.openxmlformats.org/drawingml/2006/main"/>
         </p:blipFill>
         <p:spPr>
@@ -4935,7 +4710,7 @@
                 <a:ea typeface="Arial"/>
                 <a:cs typeface="Arial"/>
               </a:rPr>
-              <a:t>A  Improve the repair</a:t>
+              <a:t>A  The repair is already done</a:t>
             </a:r>
           </a:p>
         </p:txBody>
@@ -4949,7 +4724,7 @@
           <p:nvPr/>
         </p:nvPicPr>
         <p:blipFill>
-          <a:blip xmlns:r="http://schemas.openxmlformats.org/officeDocument/2006/relationships" xmlns:a="http://schemas.openxmlformats.org/drawingml/2006/main" r:embed="R4e0638f7620a4b41"/>
+          <a:blip xmlns:r="http://schemas.openxmlformats.org/officeDocument/2006/relationships" xmlns:a="http://schemas.openxmlformats.org/drawingml/2006/main" r:embed="Rf2b2033a76074010"/>
           <a:stretch xmlns:a="http://schemas.openxmlformats.org/drawingml/2006/main"/>
         </p:blipFill>
         <p:spPr>
@@ -5015,7 +4790,7 @@
                 <a:ea typeface="Arial"/>
                 <a:cs typeface="Arial"/>
               </a:rPr>
-              <a:t>B  Learn customer preferences</a:t>
+              <a:t>B  Colors do not fix pickup</a:t>
             </a:r>
           </a:p>
         </p:txBody>
@@ -5029,7 +4804,7 @@
           <p:nvPr/>
         </p:nvPicPr>
         <p:blipFill>
-          <a:blip xmlns:r="http://schemas.openxmlformats.org/officeDocument/2006/relationships" xmlns:a="http://schemas.openxmlformats.org/drawingml/2006/main" r:embed="Rd3fc59e6328a4367"/>
+          <a:blip xmlns:r="http://schemas.openxmlformats.org/officeDocument/2006/relationships" xmlns:a="http://schemas.openxmlformats.org/drawingml/2006/main" r:embed="R47cbdf6c808d4ef1"/>
           <a:stretch xmlns:a="http://schemas.openxmlformats.org/drawingml/2006/main"/>
         </p:blipFill>
         <p:spPr>
@@ -5095,7 +4870,7 @@
                 <a:ea typeface="Arial"/>
                 <a:cs typeface="Arial"/>
               </a:rPr>
-              <a:t>C  Arrange bike pickup</a:t>
+              <a:t>C  A time the customer can use</a:t>
             </a:r>
           </a:p>
         </p:txBody>
@@ -5183,7 +4958,7 @@
                 <a:ea typeface="Arial"/>
                 <a:cs typeface="Arial"/>
               </a:rPr>
-              <a:t>It coordinates how, when, and where products reach customers.</a:t>
+              <a:t>Channel management: plan how, when, and where customers get products.</a:t>
             </a:r>
           </a:p>
         </p:txBody>
@@ -5474,7 +5249,7 @@
                 <a:ea typeface="Arial"/>
                 <a:cs typeface="Arial"/>
               </a:rPr>
-              <a:t>A service needs a workable way to reach customers.</a:t>
+              <a:t>A finished repair still needs a workable pickup.</a:t>
             </a:r>
           </a:p>
         </p:txBody>
@@ -5532,7 +5307,7 @@
                 <a:ea typeface="Arial"/>
                 <a:cs typeface="Arial"/>
               </a:rPr>
-              <a:t>Keep this example in mind as you read.</a:t>
+              <a:t>The repair stays the same. The pickup arrangement changes.</a:t>
             </a:r>
           </a:p>
         </p:txBody>
@@ -5546,7 +5321,7 @@
           <p:nvPr/>
         </p:nvPicPr>
         <p:blipFill>
-          <a:blip xmlns:r="http://schemas.openxmlformats.org/officeDocument/2006/relationships" xmlns:a="http://schemas.openxmlformats.org/drawingml/2006/main" r:embed="R075eb0c19c75438d"/>
+          <a:blip xmlns:r="http://schemas.openxmlformats.org/officeDocument/2006/relationships" xmlns:a="http://schemas.openxmlformats.org/drawingml/2006/main" r:embed="Rc9252f4f173a4c42"/>
           <a:stretch xmlns:a="http://schemas.openxmlformats.org/drawingml/2006/main"/>
         </p:blipFill>
         <p:spPr>
@@ -6179,7 +5954,7 @@
           <p:nvPr/>
         </p:nvPicPr>
         <p:blipFill>
-          <a:blip xmlns:r="http://schemas.openxmlformats.org/officeDocument/2006/relationships" xmlns:a="http://schemas.openxmlformats.org/drawingml/2006/main" r:embed="R07e3e318f1044145"/>
+          <a:blip xmlns:r="http://schemas.openxmlformats.org/officeDocument/2006/relationships" xmlns:a="http://schemas.openxmlformats.org/drawingml/2006/main" r:embed="Re5a45d163c0e4a71"/>
           <a:stretch xmlns:a="http://schemas.openxmlformats.org/drawingml/2006/main"/>
         </p:blipFill>
         <p:spPr>
@@ -6259,7 +6034,7 @@
           <p:nvPr/>
         </p:nvPicPr>
         <p:blipFill>
-          <a:blip xmlns:r="http://schemas.openxmlformats.org/officeDocument/2006/relationships" xmlns:a="http://schemas.openxmlformats.org/drawingml/2006/main" r:embed="Rad2d3dd8df354e80"/>
+          <a:blip xmlns:r="http://schemas.openxmlformats.org/officeDocument/2006/relationships" xmlns:a="http://schemas.openxmlformats.org/drawingml/2006/main" r:embed="Re6f52013d07f46a6"/>
           <a:stretch xmlns:a="http://schemas.openxmlformats.org/drawingml/2006/main"/>
         </p:blipFill>
         <p:spPr>
@@ -6339,7 +6114,7 @@
           <p:nvPr/>
         </p:nvPicPr>
         <p:blipFill>
-          <a:blip xmlns:r="http://schemas.openxmlformats.org/officeDocument/2006/relationships" xmlns:a="http://schemas.openxmlformats.org/drawingml/2006/main" r:embed="R296a475ba8e44bcc"/>
+          <a:blip xmlns:r="http://schemas.openxmlformats.org/officeDocument/2006/relationships" xmlns:a="http://schemas.openxmlformats.org/drawingml/2006/main" r:embed="R32195e8e809e4a31"/>
           <a:stretch xmlns:a="http://schemas.openxmlformats.org/drawingml/2006/main"/>
         </p:blipFill>
         <p:spPr>
@@ -6856,7 +6631,7 @@
           <p:nvPr/>
         </p:nvPicPr>
         <p:blipFill>
-          <a:blip xmlns:r="http://schemas.openxmlformats.org/officeDocument/2006/relationships" xmlns:a="http://schemas.openxmlformats.org/drawingml/2006/main" r:embed="Rfaae20ea466c447b"/>
+          <a:blip xmlns:r="http://schemas.openxmlformats.org/officeDocument/2006/relationships" xmlns:a="http://schemas.openxmlformats.org/drawingml/2006/main" r:embed="R55e5e61d990f443a"/>
           <a:stretch xmlns:a="http://schemas.openxmlformats.org/drawingml/2006/main"/>
         </p:blipFill>
         <p:spPr>
@@ -6936,7 +6711,7 @@
           <p:nvPr/>
         </p:nvPicPr>
         <p:blipFill>
-          <a:blip xmlns:r="http://schemas.openxmlformats.org/officeDocument/2006/relationships" xmlns:a="http://schemas.openxmlformats.org/drawingml/2006/main" r:embed="Re676e1095ee642c3"/>
+          <a:blip xmlns:r="http://schemas.openxmlformats.org/officeDocument/2006/relationships" xmlns:a="http://schemas.openxmlformats.org/drawingml/2006/main" r:embed="Ra750addeb1dd4b2b"/>
           <a:stretch xmlns:a="http://schemas.openxmlformats.org/drawingml/2006/main"/>
         </p:blipFill>
         <p:spPr>
@@ -7016,7 +6791,7 @@
           <p:nvPr/>
         </p:nvPicPr>
         <p:blipFill>
-          <a:blip xmlns:r="http://schemas.openxmlformats.org/officeDocument/2006/relationships" xmlns:a="http://schemas.openxmlformats.org/drawingml/2006/main" r:embed="R93a0b61c5b384e8d"/>
+          <a:blip xmlns:r="http://schemas.openxmlformats.org/officeDocument/2006/relationships" xmlns:a="http://schemas.openxmlformats.org/drawingml/2006/main" r:embed="Rf945baa1e1964f17"/>
           <a:stretch xmlns:a="http://schemas.openxmlformats.org/drawingml/2006/main"/>
         </p:blipFill>
         <p:spPr>
@@ -7533,7 +7308,7 @@
           <p:nvPr/>
         </p:nvPicPr>
         <p:blipFill>
-          <a:blip xmlns:r="http://schemas.openxmlformats.org/officeDocument/2006/relationships" xmlns:a="http://schemas.openxmlformats.org/drawingml/2006/main" r:embed="R0580c992e3044d99"/>
+          <a:blip xmlns:r="http://schemas.openxmlformats.org/officeDocument/2006/relationships" xmlns:a="http://schemas.openxmlformats.org/drawingml/2006/main" r:embed="Re74846219fd24bcc"/>
           <a:stretch xmlns:a="http://schemas.openxmlformats.org/drawingml/2006/main"/>
         </p:blipFill>
         <p:spPr>
@@ -8166,7 +7941,7 @@
           <p:nvPr/>
         </p:nvPicPr>
         <p:blipFill>
-          <a:blip xmlns:r="http://schemas.openxmlformats.org/officeDocument/2006/relationships" xmlns:a="http://schemas.openxmlformats.org/drawingml/2006/main" r:embed="R6b56bdc7f1104e9d"/>
+          <a:blip xmlns:r="http://schemas.openxmlformats.org/officeDocument/2006/relationships" xmlns:a="http://schemas.openxmlformats.org/drawingml/2006/main" r:embed="R7e40992869a54c9d"/>
           <a:srcRect xmlns:a="http://schemas.openxmlformats.org/drawingml/2006/main" l="0" t="18754" r="0" b="18754"/>
           <a:stretch xmlns:a="http://schemas.openxmlformats.org/drawingml/2006/main">
             <a:fillRect l="0" t="0" r="0" b="0"/>
@@ -8249,7 +8024,7 @@
           <p:nvPr/>
         </p:nvPicPr>
         <p:blipFill>
-          <a:blip xmlns:r="http://schemas.openxmlformats.org/officeDocument/2006/relationships" xmlns:a="http://schemas.openxmlformats.org/drawingml/2006/main" r:embed="Rdcb13b90066b473f"/>
+          <a:blip xmlns:r="http://schemas.openxmlformats.org/officeDocument/2006/relationships" xmlns:a="http://schemas.openxmlformats.org/drawingml/2006/main" r:embed="R217f9fc80e7a4536"/>
           <a:srcRect xmlns:a="http://schemas.openxmlformats.org/drawingml/2006/main" l="0" t="18754" r="0" b="18754"/>
           <a:stretch xmlns:a="http://schemas.openxmlformats.org/drawingml/2006/main">
             <a:fillRect l="0" t="0" r="0" b="0"/>
@@ -8332,7 +8107,7 @@
           <p:nvPr/>
         </p:nvPicPr>
         <p:blipFill>
-          <a:blip xmlns:r="http://schemas.openxmlformats.org/officeDocument/2006/relationships" xmlns:a="http://schemas.openxmlformats.org/drawingml/2006/main" r:embed="R8e0b9cada6564b59"/>
+          <a:blip xmlns:r="http://schemas.openxmlformats.org/officeDocument/2006/relationships" xmlns:a="http://schemas.openxmlformats.org/drawingml/2006/main" r:embed="R304c89fba8a34984"/>
           <a:srcRect xmlns:a="http://schemas.openxmlformats.org/drawingml/2006/main" l="0" t="18754" r="0" b="18754"/>
           <a:stretch xmlns:a="http://schemas.openxmlformats.org/drawingml/2006/main">
             <a:fillRect l="0" t="0" r="0" b="0"/>
@@ -8852,7 +8627,7 @@
           <p:nvPr/>
         </p:nvPicPr>
         <p:blipFill>
-          <a:blip xmlns:r="http://schemas.openxmlformats.org/officeDocument/2006/relationships" xmlns:a="http://schemas.openxmlformats.org/drawingml/2006/main" r:embed="R0d19ea0ff46f4d3c"/>
+          <a:blip xmlns:r="http://schemas.openxmlformats.org/officeDocument/2006/relationships" xmlns:a="http://schemas.openxmlformats.org/drawingml/2006/main" r:embed="R4f8fdd97eab14997"/>
           <a:srcRect xmlns:a="http://schemas.openxmlformats.org/drawingml/2006/main" l="0" t="21115" r="0" b="21115"/>
           <a:stretch xmlns:a="http://schemas.openxmlformats.org/drawingml/2006/main">
             <a:fillRect l="0" t="0" r="0" b="0"/>
@@ -8935,7 +8710,7 @@
           <p:nvPr/>
         </p:nvPicPr>
         <p:blipFill>
-          <a:blip xmlns:r="http://schemas.openxmlformats.org/officeDocument/2006/relationships" xmlns:a="http://schemas.openxmlformats.org/drawingml/2006/main" r:embed="Ra1dcde0f81584510"/>
+          <a:blip xmlns:r="http://schemas.openxmlformats.org/officeDocument/2006/relationships" xmlns:a="http://schemas.openxmlformats.org/drawingml/2006/main" r:embed="R7f21378c5e944251"/>
           <a:srcRect xmlns:a="http://schemas.openxmlformats.org/drawingml/2006/main" l="0" t="21115" r="0" b="21115"/>
           <a:stretch xmlns:a="http://schemas.openxmlformats.org/drawingml/2006/main">
             <a:fillRect l="0" t="0" r="0" b="0"/>
@@ -9018,7 +8793,7 @@
           <p:nvPr/>
         </p:nvPicPr>
         <p:blipFill>
-          <a:blip xmlns:r="http://schemas.openxmlformats.org/officeDocument/2006/relationships" xmlns:a="http://schemas.openxmlformats.org/drawingml/2006/main" r:embed="R86e6a13518b3491d"/>
+          <a:blip xmlns:r="http://schemas.openxmlformats.org/officeDocument/2006/relationships" xmlns:a="http://schemas.openxmlformats.org/drawingml/2006/main" r:embed="Rf3496aec3e204811"/>
           <a:srcRect xmlns:a="http://schemas.openxmlformats.org/drawingml/2006/main" l="0" t="21115" r="0" b="21115"/>
           <a:stretch xmlns:a="http://schemas.openxmlformats.org/drawingml/2006/main">
             <a:fillRect l="0" t="0" r="0" b="0"/>
@@ -9538,7 +9313,7 @@
           <p:nvPr/>
         </p:nvPicPr>
         <p:blipFill>
-          <a:blip xmlns:r="http://schemas.openxmlformats.org/officeDocument/2006/relationships" xmlns:a="http://schemas.openxmlformats.org/drawingml/2006/main" r:embed="Raba2e9bd337145b1"/>
+          <a:blip xmlns:r="http://schemas.openxmlformats.org/officeDocument/2006/relationships" xmlns:a="http://schemas.openxmlformats.org/drawingml/2006/main" r:embed="Rc9f55663b8cb47e8"/>
           <a:srcRect xmlns:a="http://schemas.openxmlformats.org/drawingml/2006/main" l="0" t="21318" r="0" b="21318"/>
           <a:stretch xmlns:a="http://schemas.openxmlformats.org/drawingml/2006/main">
             <a:fillRect l="0" t="0" r="0" b="0"/>
@@ -10116,7 +9891,7 @@
           <p:nvPr/>
         </p:nvPicPr>
         <p:blipFill>
-          <a:blip xmlns:r="http://schemas.openxmlformats.org/officeDocument/2006/relationships" xmlns:a="http://schemas.openxmlformats.org/drawingml/2006/main" r:embed="R0c9b8020b0b94deb"/>
+          <a:blip xmlns:r="http://schemas.openxmlformats.org/officeDocument/2006/relationships" xmlns:a="http://schemas.openxmlformats.org/drawingml/2006/main" r:embed="R91e223ea40524ca4"/>
           <a:stretch xmlns:a="http://schemas.openxmlformats.org/drawingml/2006/main"/>
         </p:blipFill>
         <p:spPr>
@@ -10196,7 +9971,7 @@
           <p:nvPr/>
         </p:nvPicPr>
         <p:blipFill>
-          <a:blip xmlns:r="http://schemas.openxmlformats.org/officeDocument/2006/relationships" xmlns:a="http://schemas.openxmlformats.org/drawingml/2006/main" r:embed="Re5f2d04696a94395"/>
+          <a:blip xmlns:r="http://schemas.openxmlformats.org/officeDocument/2006/relationships" xmlns:a="http://schemas.openxmlformats.org/drawingml/2006/main" r:embed="R0803fe68a3ae427a"/>
           <a:stretch xmlns:a="http://schemas.openxmlformats.org/drawingml/2006/main"/>
         </p:blipFill>
         <p:spPr>
@@ -10276,7 +10051,7 @@
           <p:nvPr/>
         </p:nvPicPr>
         <p:blipFill>
-          <a:blip xmlns:r="http://schemas.openxmlformats.org/officeDocument/2006/relationships" xmlns:a="http://schemas.openxmlformats.org/drawingml/2006/main" r:embed="R3f6ce5f990d440b1"/>
+          <a:blip xmlns:r="http://schemas.openxmlformats.org/officeDocument/2006/relationships" xmlns:a="http://schemas.openxmlformats.org/drawingml/2006/main" r:embed="R2973b147aa5d45e4"/>
           <a:stretch xmlns:a="http://schemas.openxmlformats.org/drawingml/2006/main"/>
         </p:blipFill>
         <p:spPr>
@@ -10793,7 +10568,7 @@
           <p:nvPr/>
         </p:nvPicPr>
         <p:blipFill>
-          <a:blip xmlns:r="http://schemas.openxmlformats.org/officeDocument/2006/relationships" xmlns:a="http://schemas.openxmlformats.org/drawingml/2006/main" r:embed="R0ba69026be0f4a6d"/>
+          <a:blip xmlns:r="http://schemas.openxmlformats.org/officeDocument/2006/relationships" xmlns:a="http://schemas.openxmlformats.org/drawingml/2006/main" r:embed="Rb0ba9f075e234406"/>
           <a:stretch xmlns:a="http://schemas.openxmlformats.org/drawingml/2006/main"/>
         </p:blipFill>
         <p:spPr>
@@ -11296,7 +11071,7 @@
                 <a:ea typeface="Arial"/>
                 <a:cs typeface="Arial"/>
               </a:rPr>
-              <a:t>The snacks arrive after everyone leaves</a:t>
+              <a:t>Ordered ahead. Delivered too late.</a:t>
             </a:r>
           </a:p>
         </p:txBody>
@@ -11354,7 +11129,7 @@
                 <a:ea typeface="Arial"/>
                 <a:cs typeface="Arial"/>
               </a:rPr>
-              <a:t>A fictional popcorn order arrives AFTER the school event.</a:t>
+              <a:t>The school club ordered popcorn early. It arrived after the game.</a:t>
             </a:r>
           </a:p>
         </p:txBody>
@@ -11412,7 +11187,7 @@
                 <a:ea typeface="Arial"/>
                 <a:cs typeface="Arial"/>
               </a:rPr>
-              <a:t>Which change fixes the problem?</a:t>
+              <a:t>What should the seller fix for the next game?</a:t>
             </a:r>
           </a:p>
         </p:txBody>
@@ -11426,7 +11201,7 @@
           <p:nvPr/>
         </p:nvPicPr>
         <p:blipFill>
-          <a:blip xmlns:r="http://schemas.openxmlformats.org/officeDocument/2006/relationships" xmlns:a="http://schemas.openxmlformats.org/drawingml/2006/main" r:embed="R6eee44d9190e4010"/>
+          <a:blip xmlns:r="http://schemas.openxmlformats.org/officeDocument/2006/relationships" xmlns:a="http://schemas.openxmlformats.org/drawingml/2006/main" r:embed="Rf76e0f14231e4597"/>
           <a:stretch xmlns:a="http://schemas.openxmlformats.org/drawingml/2006/main"/>
         </p:blipFill>
         <p:spPr>
@@ -11506,7 +11281,7 @@
           <p:nvPr/>
         </p:nvPicPr>
         <p:blipFill>
-          <a:blip xmlns:r="http://schemas.openxmlformats.org/officeDocument/2006/relationships" xmlns:a="http://schemas.openxmlformats.org/drawingml/2006/main" r:embed="R482e1877c0ff4790"/>
+          <a:blip xmlns:r="http://schemas.openxmlformats.org/officeDocument/2006/relationships" xmlns:a="http://schemas.openxmlformats.org/drawingml/2006/main" r:embed="R96a3fddc8c8c4dd1"/>
           <a:stretch xmlns:a="http://schemas.openxmlformats.org/drawingml/2006/main"/>
         </p:blipFill>
         <p:spPr>
@@ -11586,7 +11361,7 @@
           <p:nvPr/>
         </p:nvPicPr>
         <p:blipFill>
-          <a:blip xmlns:r="http://schemas.openxmlformats.org/officeDocument/2006/relationships" xmlns:a="http://schemas.openxmlformats.org/drawingml/2006/main" r:embed="Rc38a4182540b4d42"/>
+          <a:blip xmlns:r="http://schemas.openxmlformats.org/officeDocument/2006/relationships" xmlns:a="http://schemas.openxmlformats.org/drawingml/2006/main" r:embed="R2e7feab1d85446c1"/>
           <a:stretch xmlns:a="http://schemas.openxmlformats.org/drawingml/2006/main"/>
         </p:blipFill>
         <p:spPr>
@@ -11652,7 +11427,7 @@
                 <a:ea typeface="Arial"/>
                 <a:cs typeface="Arial"/>
               </a:rPr>
-              <a:t>C  Deliver before the event</a:t>
+              <a:t>C  Deliver before the game</a:t>
             </a:r>
           </a:p>
         </p:txBody>
@@ -12031,7 +11806,7 @@
                 <a:ea typeface="Arial"/>
                 <a:cs typeface="Arial"/>
               </a:rPr>
-              <a:t>C  Deliver before the event</a:t>
+              <a:t>C  Deliver before the game</a:t>
             </a:r>
           </a:p>
         </p:txBody>
@@ -12103,7 +11878,7 @@
           <p:nvPr/>
         </p:nvPicPr>
         <p:blipFill>
-          <a:blip xmlns:r="http://schemas.openxmlformats.org/officeDocument/2006/relationships" xmlns:a="http://schemas.openxmlformats.org/drawingml/2006/main" r:embed="R15afd763404d4558"/>
+          <a:blip xmlns:r="http://schemas.openxmlformats.org/officeDocument/2006/relationships" xmlns:a="http://schemas.openxmlformats.org/drawingml/2006/main" r:embed="Rcb2947851b184c58"/>
           <a:stretch xmlns:a="http://schemas.openxmlformats.org/drawingml/2006/main"/>
         </p:blipFill>
         <p:spPr>
@@ -12169,7 +11944,7 @@
                 <a:ea typeface="Arial"/>
                 <a:cs typeface="Arial"/>
               </a:rPr>
-              <a:t>PRODUCT: the snack</a:t>
+              <a:t>A  New packaging: product</a:t>
             </a:r>
           </a:p>
         </p:txBody>
@@ -12183,7 +11958,7 @@
           <p:nvPr/>
         </p:nvPicPr>
         <p:blipFill>
-          <a:blip xmlns:r="http://schemas.openxmlformats.org/officeDocument/2006/relationships" xmlns:a="http://schemas.openxmlformats.org/drawingml/2006/main" r:embed="R39e00425bb944c45"/>
+          <a:blip xmlns:r="http://schemas.openxmlformats.org/officeDocument/2006/relationships" xmlns:a="http://schemas.openxmlformats.org/drawingml/2006/main" r:embed="R526acd8495094902"/>
           <a:stretch xmlns:a="http://schemas.openxmlformats.org/drawingml/2006/main"/>
         </p:blipFill>
         <p:spPr>
@@ -12249,7 +12024,7 @@
                 <a:ea typeface="Arial"/>
                 <a:cs typeface="Arial"/>
               </a:rPr>
-              <a:t>PROMOTION: the message</a:t>
+              <a:t>B  Bigger ad: promotion</a:t>
             </a:r>
           </a:p>
         </p:txBody>
@@ -12263,7 +12038,7 @@
           <p:nvPr/>
         </p:nvPicPr>
         <p:blipFill>
-          <a:blip xmlns:r="http://schemas.openxmlformats.org/officeDocument/2006/relationships" xmlns:a="http://schemas.openxmlformats.org/drawingml/2006/main" r:embed="R9bc2e2d72e8346c1"/>
+          <a:blip xmlns:r="http://schemas.openxmlformats.org/officeDocument/2006/relationships" xmlns:a="http://schemas.openxmlformats.org/drawingml/2006/main" r:embed="R19e4f6dee3e34155"/>
           <a:stretch xmlns:a="http://schemas.openxmlformats.org/drawingml/2006/main"/>
         </p:blipFill>
         <p:spPr>
@@ -12329,7 +12104,7 @@
                 <a:ea typeface="Arial"/>
                 <a:cs typeface="Arial"/>
               </a:rPr>
-              <a:t>PLACE: the route to you</a:t>
+              <a:t>C  Timely delivery: place</a:t>
             </a:r>
           </a:p>
         </p:txBody>
@@ -12780,7 +12555,7 @@
           <p:nvPr/>
         </p:nvPicPr>
         <p:blipFill>
-          <a:blip xmlns:r="http://schemas.openxmlformats.org/officeDocument/2006/relationships" xmlns:a="http://schemas.openxmlformats.org/drawingml/2006/main" r:embed="Rb91a9250622a4da7"/>
+          <a:blip xmlns:r="http://schemas.openxmlformats.org/officeDocument/2006/relationships" xmlns:a="http://schemas.openxmlformats.org/drawingml/2006/main" r:embed="R7cb47026edd74c16"/>
           <a:stretch xmlns:a="http://schemas.openxmlformats.org/drawingml/2006/main"/>
         </p:blipFill>
         <p:spPr>
@@ -13413,7 +13188,7 @@
           <p:nvPr/>
         </p:nvPicPr>
         <p:blipFill>
-          <a:blip xmlns:r="http://schemas.openxmlformats.org/officeDocument/2006/relationships" xmlns:a="http://schemas.openxmlformats.org/drawingml/2006/main" r:embed="R5a2cbfd3a8324861"/>
+          <a:blip xmlns:r="http://schemas.openxmlformats.org/officeDocument/2006/relationships" xmlns:a="http://schemas.openxmlformats.org/drawingml/2006/main" r:embed="R439838d12e504729"/>
           <a:stretch xmlns:a="http://schemas.openxmlformats.org/drawingml/2006/main"/>
         </p:blipFill>
         <p:spPr>
@@ -13755,7 +13530,7 @@
           <p:nvPr/>
         </p:nvPicPr>
         <p:blipFill>
-          <a:blip xmlns:r="http://schemas.openxmlformats.org/officeDocument/2006/relationships" xmlns:a="http://schemas.openxmlformats.org/drawingml/2006/main" r:embed="Rf017bad760b84b88"/>
+          <a:blip xmlns:r="http://schemas.openxmlformats.org/officeDocument/2006/relationships" xmlns:a="http://schemas.openxmlformats.org/drawingml/2006/main" r:embed="R58a9b01c59e54aef"/>
           <a:stretch xmlns:a="http://schemas.openxmlformats.org/drawingml/2006/main"/>
         </p:blipFill>
         <p:spPr>
@@ -13777,7 +13552,7 @@
           <p:nvPr/>
         </p:nvPicPr>
         <p:blipFill>
-          <a:blip xmlns:r="http://schemas.openxmlformats.org/officeDocument/2006/relationships" xmlns:a="http://schemas.openxmlformats.org/drawingml/2006/main" r:embed="Ra17a9434d98e463c"/>
+          <a:blip xmlns:r="http://schemas.openxmlformats.org/officeDocument/2006/relationships" xmlns:a="http://schemas.openxmlformats.org/drawingml/2006/main" r:embed="Rde4fa90a34a54af3"/>
           <a:stretch xmlns:a="http://schemas.openxmlformats.org/drawingml/2006/main"/>
         </p:blipFill>
         <p:spPr>
@@ -14083,14 +13858,14 @@
       </p:sp>
       <p:pic>
         <p:nvPicPr>
-          <p:cNvPr id="22" name=""/>
+          <p:cNvPr id="25" name=""/>
           <p:cNvPicPr>
             <a:picLocks xmlns:a="http://schemas.openxmlformats.org/drawingml/2006/main" noChangeAspect="1"/>
           </p:cNvPicPr>
           <p:nvPr/>
         </p:nvPicPr>
         <p:blipFill>
-          <a:blip xmlns:r="http://schemas.openxmlformats.org/officeDocument/2006/relationships" xmlns:a="http://schemas.openxmlformats.org/drawingml/2006/main" r:embed="R014c9c240b08491f"/>
+          <a:blip xmlns:r="http://schemas.openxmlformats.org/officeDocument/2006/relationships" xmlns:a="http://schemas.openxmlformats.org/drawingml/2006/main" r:embed="R4ad0362e270d4f89"/>
           <a:stretch xmlns:a="http://schemas.openxmlformats.org/drawingml/2006/main"/>
         </p:blipFill>
         <p:spPr>
@@ -14367,14 +14142,14 @@
       </p:sp>
       <p:pic>
         <p:nvPicPr>
-          <p:cNvPr id="28" name=""/>
+          <p:cNvPr id="31" name=""/>
           <p:cNvPicPr>
             <a:picLocks xmlns:a="http://schemas.openxmlformats.org/drawingml/2006/main" noChangeAspect="1"/>
           </p:cNvPicPr>
           <p:nvPr/>
         </p:nvPicPr>
         <p:blipFill>
-          <a:blip xmlns:r="http://schemas.openxmlformats.org/officeDocument/2006/relationships" xmlns:a="http://schemas.openxmlformats.org/drawingml/2006/main" r:embed="Re2a34e5f8f0247e2"/>
+          <a:blip xmlns:r="http://schemas.openxmlformats.org/officeDocument/2006/relationships" xmlns:a="http://schemas.openxmlformats.org/drawingml/2006/main" r:embed="R4e0d285f1a384997"/>
           <a:stretch xmlns:a="http://schemas.openxmlformats.org/drawingml/2006/main"/>
         </p:blipFill>
         <p:spPr>
@@ -14389,14 +14164,14 @@
       </p:pic>
       <p:pic>
         <p:nvPicPr>
-          <p:cNvPr id="29" name=""/>
+          <p:cNvPr id="32" name=""/>
           <p:cNvPicPr>
             <a:picLocks xmlns:a="http://schemas.openxmlformats.org/drawingml/2006/main" noChangeAspect="1"/>
           </p:cNvPicPr>
           <p:nvPr/>
         </p:nvPicPr>
         <p:blipFill>
-          <a:blip xmlns:r="http://schemas.openxmlformats.org/officeDocument/2006/relationships" xmlns:a="http://schemas.openxmlformats.org/drawingml/2006/main" r:embed="R2d6f08c1e9724874"/>
+          <a:blip xmlns:r="http://schemas.openxmlformats.org/officeDocument/2006/relationships" xmlns:a="http://schemas.openxmlformats.org/drawingml/2006/main" r:embed="Ra649ada1e7984f80"/>
           <a:stretch xmlns:a="http://schemas.openxmlformats.org/drawingml/2006/main"/>
         </p:blipFill>
         <p:spPr>
@@ -14443,6 +14218,7 @@
           <a:lstStyle xmlns:a="http://schemas.openxmlformats.org/drawingml/2006/main"/>
           <a:p xmlns:a="http://schemas.openxmlformats.org/drawingml/2006/main">
             <a:pPr>
+              <a:buNone/>
               <a:defRPr sz="2025" b="1">
                 <a:solidFill>
                   <a:srgbClr val="17334D"/>
@@ -14766,7 +14542,7 @@
           <p:nvPr/>
         </p:nvPicPr>
         <p:blipFill>
-          <a:blip xmlns:r="http://schemas.openxmlformats.org/officeDocument/2006/relationships" xmlns:a="http://schemas.openxmlformats.org/drawingml/2006/main" r:embed="Rab1efaa1fcdc415f"/>
+          <a:blip xmlns:r="http://schemas.openxmlformats.org/officeDocument/2006/relationships" xmlns:a="http://schemas.openxmlformats.org/drawingml/2006/main" r:embed="R5cb4fad019b74a3d"/>
           <a:stretch xmlns:a="http://schemas.openxmlformats.org/drawingml/2006/main"/>
         </p:blipFill>
         <p:spPr>

</xml_diff>